<commit_message>
feat: render microsoft-plugin-architecture revision 04 with four voices
- add Michael, Heart and Bella on Kokoro ONNX and Michael on PyTorch Kokoro
- master all variants to -16 LUFS and refresh analysis and Office QA

🎙️ - Generated by Copilot

Co-authored-by: Copilot <223556219+Copilot@users.noreply.github.com>
</commit_message>
<xml_diff>
--- a/projects/microsoft-plugin-architecture/release/outputs/deck.pptx
+++ b/projects/microsoft-plugin-architecture/release/outputs/deck.pptx
@@ -1294,7 +1294,7 @@
                   <a:srgbClr val="B4B5C4"/>
                 </a:solidFill>
               </a:rPr>
-              <a:t>microsoft-plugin-architecture-r2</a:t>
+              <a:t>microsoft-plugin-architecture-2026-04-am-michael-kokoro-onnx</a:t>
             </a:r>
           </a:p>
         </p:txBody>
@@ -1570,7 +1570,7 @@
                   <a:srgbClr val="B4B5C4"/>
                 </a:solidFill>
               </a:rPr>
-              <a:t>Sources: [ev-01] Build plugins for Copilot Cowork  ·  [ev-02] Build plugins for Copilot Cowork  ·  [ev-04] MCP and API plugins for declarative agents</a:t>
+              <a:t>Sources: Build plugins for Copilot Cowork  ·  MCP and API plugins for declarative agents  ·  About GitHub Copilot plugins</a:t>
             </a:r>
           </a:p>
         </p:txBody>
@@ -1846,7 +1846,7 @@
                   <a:srgbClr val="B4B5C4"/>
                 </a:solidFill>
               </a:rPr>
-              <a:t>Sources: [ev-03] Build plugins for Copilot Cowork  ·  [ev-07] About GitHub Copilot plugins  ·  [ev-08] About GitHub Copilot plugins</a:t>
+              <a:t>Sources: Build plugins for Copilot Cowork  ·  About GitHub Copilot plugins</a:t>
             </a:r>
           </a:p>
         </p:txBody>
@@ -2122,7 +2122,7 @@
                   <a:srgbClr val="B4B5C4"/>
                 </a:solidFill>
               </a:rPr>
-              <a:t>Sources: [ev-04] MCP and API plugins for declarative agents  ·  [ev-05] MCP and API plugins for declarative agents  ·  [ev-06] MCP and API plugins for declarative agents</a:t>
+              <a:t>Sources: MCP and API plugins for declarative agents  ·  About GitHub Copilot plugins</a:t>
             </a:r>
           </a:p>
         </p:txBody>
@@ -2398,7 +2398,7 @@
                   <a:srgbClr val="B4B5C4"/>
                 </a:solidFill>
               </a:rPr>
-              <a:t>Sources: [ev-01] Build plugins for Copilot Cowork  ·  [ev-02] Build plugins for Copilot Cowork  ·  [ev-04] MCP and API plugins for declarative agents</a:t>
+              <a:t>Sources: Build plugins for Copilot Cowork  ·  MCP and API plugins for declarative agents  ·  About GitHub Copilot plugins</a:t>
             </a:r>
           </a:p>
         </p:txBody>
@@ -2574,7 +2574,7 @@
               </a:spcAft>
             </a:pPr>
             <a:r>
-              <a:rPr lang="en-US" sz="1800" b="1">
+              <a:rPr lang="en-US" sz="1400" b="1">
                 <a:solidFill>
                   <a:srgbClr val="F7F4FF"/>
                 </a:solidFill>
@@ -2582,7 +2582,7 @@
               <a:t>Build plugins for Copilot Cowork</a:t>
             </a:r>
             <a:r>
-              <a:rPr lang="en-US" sz="1200">
+              <a:rPr lang="en-US" sz="1100">
                 <a:solidFill>
                   <a:srgbClr val="B4B5C4"/>
                 </a:solidFill>
@@ -2596,11 +2596,11 @@
                 <a:spcPct val="105000"/>
               </a:lnSpc>
               <a:spcAft>
-                <a:spcPts val="1400"/>
+                <a:spcPts val="900"/>
               </a:spcAft>
             </a:pPr>
             <a:r>
-              <a:rPr lang="en-US" sz="1400">
+              <a:rPr lang="en-US" sz="1100">
                 <a:solidFill>
                   <a:srgbClr val="8B5CF6"/>
                 </a:solidFill>
@@ -2618,7 +2618,7 @@
               </a:spcAft>
             </a:pPr>
             <a:r>
-              <a:rPr lang="en-US" sz="1800" b="1">
+              <a:rPr lang="en-US" sz="1400" b="1">
                 <a:solidFill>
                   <a:srgbClr val="F7F4FF"/>
                 </a:solidFill>
@@ -2626,7 +2626,7 @@
               <a:t>MCP and API plugins for declarative agents</a:t>
             </a:r>
             <a:r>
-              <a:rPr lang="en-US" sz="1200">
+              <a:rPr lang="en-US" sz="1100">
                 <a:solidFill>
                   <a:srgbClr val="B4B5C4"/>
                 </a:solidFill>
@@ -2640,11 +2640,11 @@
                 <a:spcPct val="105000"/>
               </a:lnSpc>
               <a:spcAft>
-                <a:spcPts val="1400"/>
+                <a:spcPts val="900"/>
               </a:spcAft>
             </a:pPr>
             <a:r>
-              <a:rPr lang="en-US" sz="1400">
+              <a:rPr lang="en-US" sz="1100">
                 <a:solidFill>
                   <a:srgbClr val="8B5CF6"/>
                 </a:solidFill>
@@ -2662,7 +2662,7 @@
               </a:spcAft>
             </a:pPr>
             <a:r>
-              <a:rPr lang="en-US" sz="1800" b="1">
+              <a:rPr lang="en-US" sz="1400" b="1">
                 <a:solidFill>
                   <a:srgbClr val="F7F4FF"/>
                 </a:solidFill>
@@ -2670,7 +2670,7 @@
               <a:t>About GitHub Copilot plugins</a:t>
             </a:r>
             <a:r>
-              <a:rPr lang="en-US" sz="1200">
+              <a:rPr lang="en-US" sz="1100">
                 <a:solidFill>
                   <a:srgbClr val="B4B5C4"/>
                 </a:solidFill>
@@ -2684,11 +2684,11 @@
                 <a:spcPct val="105000"/>
               </a:lnSpc>
               <a:spcAft>
-                <a:spcPts val="1400"/>
+                <a:spcPts val="900"/>
               </a:spcAft>
             </a:pPr>
             <a:r>
-              <a:rPr lang="en-US" sz="1400">
+              <a:rPr lang="en-US" sz="1100">
                 <a:solidFill>
                   <a:srgbClr val="8B5CF6"/>
                 </a:solidFill>
@@ -2737,7 +2737,7 @@
                   <a:srgbClr val="B4B5C4"/>
                 </a:solidFill>
               </a:rPr>
-              <a:t>microsoft-plugin-architecture-r2</a:t>
+              <a:t>microsoft-plugin-architecture-2026-04-am-michael-kokoro-onnx</a:t>
             </a:r>
           </a:p>
         </p:txBody>

</xml_diff>

<commit_message>
feat: regenerate microsoft-plugin-architecture with LF-stable release generation
- render four voices so release-verify passes on any checkout

🎙️ - Generated by Copilot

Co-authored-by: Copilot <223556219+Copilot@users.noreply.github.com>
</commit_message>
<xml_diff>
--- a/projects/microsoft-plugin-architecture/release/outputs/deck.pptx
+++ b/projects/microsoft-plugin-architecture/release/outputs/deck.pptx
@@ -1162,7 +1162,7 @@
         <p:spPr>
           <a:xfrm>
             <a:off x="685800" y="3000000"/>
-            <a:ext cx="9600000" cy="1200000"/>
+            <a:ext cx="9600000" cy="1400000"/>
           </a:xfrm>
           <a:prstGeom prst="rect">
             <a:avLst/>
@@ -1187,7 +1187,7 @@
               </a:spcAft>
             </a:pPr>
             <a:r>
-              <a:rPr lang="en-US" sz="2000">
+              <a:rPr lang="en-US" sz="2400">
                 <a:solidFill>
                   <a:srgbClr val="B4B5C4"/>
                 </a:solidFill>
@@ -1294,7 +1294,7 @@
                   <a:srgbClr val="B4B5C4"/>
                 </a:solidFill>
               </a:rPr>
-              <a:t>microsoft-plugin-architecture-2026-04-am-michael-kokoro-onnx</a:t>
+              <a:t>microsoft-plugin-architecture-2026-05-am-michael-kokoro-onnx</a:t>
             </a:r>
           </a:p>
         </p:txBody>
@@ -2737,7 +2737,7 @@
                   <a:srgbClr val="B4B5C4"/>
                 </a:solidFill>
               </a:rPr>
-              <a:t>microsoft-plugin-architecture-2026-04-am-michael-kokoro-onnx</a:t>
+              <a:t>microsoft-plugin-architecture-2026-05-am-michael-kokoro-onnx</a:t>
             </a:r>
           </a:p>
         </p:txBody>

</xml_diff>

<commit_message>
feat: regenerate microsoft-plugin-architecture with its brand theme
- render four voices with the brand header band, palette and fonts

🎨 - Generated by Copilot

Co-authored-by: Copilot <223556219+Copilot@users.noreply.github.com>
</commit_message>
<xml_diff>
--- a/projects/microsoft-plugin-architecture/release/outputs/deck.pptx
+++ b/projects/microsoft-plugin-architecture/release/outputs/deck.pptx
@@ -18,6 +18,16 @@
     <a:defPPr>
       <a:defRPr lang="en-US"/>
     </a:defPPr>
+    <a:lvl1pPr algn="l" defTabSz="914400" marL="0" indent="0">
+      <a:defRPr sz="1800" kern="1200">
+        <a:solidFill>
+          <a:schemeClr val="tx1"/>
+        </a:solidFill>
+        <a:latin typeface="+mn-lt"/>
+        <a:ea typeface="+mn-ea"/>
+        <a:cs typeface="+mn-cs"/>
+      </a:defRPr>
+    </a:lvl1pPr>
   </p:defaultTextStyle>
 </p:presentation>
 </file>
@@ -1067,7 +1077,7 @@
     <p:bg>
       <p:bgPr>
         <a:solidFill>
-          <a:srgbClr val="08142D"/>
+          <a:srgbClr val="F4F8FC"/>
         </a:solidFill>
         <a:effectLst/>
       </p:bgPr>
@@ -1081,20 +1091,20 @@
       <p:grpSpPr/>
       <p:sp>
         <p:nvSpPr>
-          <p:cNvPr id="2" name="Accent band"/>
+          <p:cNvPr id="2" name="Brand band"/>
           <p:cNvSpPr/>
           <p:nvPr/>
         </p:nvSpPr>
         <p:spPr>
           <a:xfrm>
             <a:off x="0" y="0"/>
-            <a:ext cx="12192000" cy="91440"/>
+            <a:ext cx="12192000" cy="502920"/>
           </a:xfrm>
           <a:prstGeom prst="rect">
             <a:avLst/>
           </a:prstGeom>
           <a:solidFill>
-            <a:srgbClr val="8B5CF6"/>
+            <a:srgbClr val="0E1726"/>
           </a:solidFill>
           <a:ln>
             <a:noFill/>
@@ -1103,14 +1113,36 @@
       </p:sp>
       <p:sp>
         <p:nvSpPr>
-          <p:cNvPr id="3" name="Title"/>
-          <p:cNvSpPr txBox="1"/>
-          <p:nvPr/>
-        </p:nvSpPr>
-        <p:spPr>
-          <a:xfrm>
-            <a:off x="685800" y="900000"/>
-            <a:ext cx="10820400" cy="2000000"/>
+          <p:cNvPr id="3" name="Highlight rule"/>
+          <p:cNvSpPr/>
+          <p:nvPr/>
+        </p:nvSpPr>
+        <p:spPr>
+          <a:xfrm>
+            <a:off x="0" y="502920"/>
+            <a:ext cx="12192000" cy="45720"/>
+          </a:xfrm>
+          <a:prstGeom prst="rect">
+            <a:avLst/>
+          </a:prstGeom>
+          <a:solidFill>
+            <a:srgbClr val="8AC1EB"/>
+          </a:solidFill>
+          <a:ln>
+            <a:noFill/>
+          </a:ln>
+        </p:spPr>
+      </p:sp>
+      <p:sp>
+        <p:nvSpPr>
+          <p:cNvPr id="4" name="Deck kicker"/>
+          <p:cNvSpPr txBox="1"/>
+          <p:nvPr/>
+        </p:nvSpPr>
+        <p:spPr>
+          <a:xfrm>
+            <a:off x="685800" y="0"/>
+            <a:ext cx="8400000" cy="502920"/>
           </a:xfrm>
           <a:prstGeom prst="rect">
             <a:avLst/>
@@ -1135,45 +1167,74 @@
               </a:spcAft>
             </a:pPr>
             <a:r>
-              <a:rPr lang="en-US" sz="3600" b="1">
-                <a:solidFill>
-                  <a:srgbClr val="F7F4FF"/>
-                </a:solidFill>
-              </a:rPr>
-              <a:t>Microsoft Plugin Architecture:</a:t>
-            </a:r>
-            <a:r>
-              <a:rPr lang="en-US" sz="3600" b="1">
-                <a:solidFill>
-                  <a:srgbClr val="8B5CF6"/>
-                </a:solidFill>
-              </a:rPr>
-              <a:t> reuse the core, govern each host</a:t>
-            </a:r>
-          </a:p>
-        </p:txBody>
-      </p:sp>
-      <p:sp>
-        <p:nvSpPr>
-          <p:cNvPr id="4" name="Summary"/>
-          <p:cNvSpPr txBox="1"/>
-          <p:nvPr/>
-        </p:nvSpPr>
-        <p:spPr>
-          <a:xfrm>
-            <a:off x="685800" y="3000000"/>
-            <a:ext cx="9600000" cy="1400000"/>
-          </a:xfrm>
-          <a:prstGeom prst="rect">
-            <a:avLst/>
-          </a:prstGeom>
-          <a:noFill/>
-          <a:ln>
-            <a:noFill/>
-          </a:ln>
-        </p:spPr>
-        <p:txBody>
-          <a:bodyPr wrap="square" lIns="182880" tIns="91440" rIns="182880" bIns="91440" anchor="t">
+              <a:rPr lang="en-US" sz="1100" b="1" cap="all" spc="120">
+                <a:solidFill>
+                  <a:srgbClr val="FFFFFF"/>
+                </a:solidFill>
+              </a:rPr>
+              <a:t>Microsoft Plugin Architecture</a:t>
+            </a:r>
+          </a:p>
+        </p:txBody>
+      </p:sp>
+      <p:sp>
+        <p:nvSpPr>
+          <p:cNvPr id="5" name="Slide number"/>
+          <p:cNvSpPr txBox="1"/>
+          <p:nvPr/>
+        </p:nvSpPr>
+        <p:spPr>
+          <a:xfrm>
+            <a:off x="9100000" y="0"/>
+            <a:ext cx="2406400" cy="502920"/>
+          </a:xfrm>
+          <a:prstGeom prst="rect">
+            <a:avLst/>
+          </a:prstGeom>
+          <a:noFill/>
+          <a:ln>
+            <a:noFill/>
+          </a:ln>
+        </p:spPr>
+        <p:txBody>
+          <a:bodyPr wrap="square" lIns="182880" tIns="91440" rIns="182880" bIns="91440" anchor="ctr">
+            <a:normAutofit/>
+          </a:bodyPr>
+          <a:lstStyle/>
+          <a:p>
+            <a:pPr algn="r"/>
+            <a:r>
+              <a:rPr lang="en-US" sz="1100" b="1" cap="all" spc="120">
+                <a:solidFill>
+                  <a:srgbClr val="BCBEC2"/>
+                </a:solidFill>
+              </a:rPr>
+              <a:t>1 / 6</a:t>
+            </a:r>
+          </a:p>
+        </p:txBody>
+      </p:sp>
+      <p:sp>
+        <p:nvSpPr>
+          <p:cNvPr id="6" name="Title"/>
+          <p:cNvSpPr txBox="1"/>
+          <p:nvPr/>
+        </p:nvSpPr>
+        <p:spPr>
+          <a:xfrm>
+            <a:off x="685800" y="1100000"/>
+            <a:ext cx="10820400" cy="2000000"/>
+          </a:xfrm>
+          <a:prstGeom prst="rect">
+            <a:avLst/>
+          </a:prstGeom>
+          <a:noFill/>
+          <a:ln>
+            <a:noFill/>
+          </a:ln>
+        </p:spPr>
+        <p:txBody>
+          <a:bodyPr wrap="square" lIns="182880" tIns="91440" rIns="182880" bIns="91440" anchor="ctr">
             <a:normAutofit/>
           </a:bodyPr>
           <a:lstStyle/>
@@ -1187,43 +1248,47 @@
               </a:spcAft>
             </a:pPr>
             <a:r>
-              <a:rPr lang="en-US" sz="2400">
-                <a:solidFill>
-                  <a:srgbClr val="B4B5C4"/>
-                </a:solidFill>
-              </a:rPr>
-              <a:t>Bottom line: standardize skills and MCP, then govern compatibility and ownership for each host.</a:t>
-            </a:r>
-          </a:p>
-        </p:txBody>
-      </p:sp>
-      <p:sp>
-        <p:nvSpPr>
-          <p:cNvPr id="5" name="Decision"/>
-          <p:cNvSpPr/>
-          <p:nvPr/>
-        </p:nvSpPr>
-        <p:spPr>
-          <a:xfrm>
-            <a:off x="685800" y="4500000"/>
-            <a:ext cx="10820400" cy="1000000"/>
-          </a:xfrm>
-          <a:prstGeom prst="roundRect">
-            <a:avLst>
-              <a:gd name="adj" fmla="val 9000"/>
-            </a:avLst>
-          </a:prstGeom>
-          <a:solidFill>
-            <a:srgbClr val="1D204D"/>
-          </a:solidFill>
-          <a:ln w="12700">
-            <a:solidFill>
-              <a:srgbClr val="8B5CF6"/>
-            </a:solidFill>
-          </a:ln>
-        </p:spPr>
-        <p:txBody>
-          <a:bodyPr wrap="square" lIns="182880" tIns="91440" rIns="182880" bIns="91440" anchor="ctr">
+              <a:rPr lang="en-US" sz="3600" b="1">
+                <a:solidFill>
+                  <a:srgbClr val="0B121E"/>
+                </a:solidFill>
+                <a:latin typeface="+mj-lt"/>
+              </a:rPr>
+              <a:t>Microsoft Plugin Architecture:</a:t>
+            </a:r>
+            <a:r>
+              <a:rPr lang="en-US" sz="3600" b="1">
+                <a:solidFill>
+                  <a:srgbClr val="006EC3"/>
+                </a:solidFill>
+                <a:latin typeface="+mj-lt"/>
+              </a:rPr>
+              <a:t> reuse the core, govern each host</a:t>
+            </a:r>
+          </a:p>
+        </p:txBody>
+      </p:sp>
+      <p:sp>
+        <p:nvSpPr>
+          <p:cNvPr id="7" name="Summary"/>
+          <p:cNvSpPr txBox="1"/>
+          <p:nvPr/>
+        </p:nvSpPr>
+        <p:spPr>
+          <a:xfrm>
+            <a:off x="685800" y="3150000"/>
+            <a:ext cx="9600000" cy="1400000"/>
+          </a:xfrm>
+          <a:prstGeom prst="rect">
+            <a:avLst/>
+          </a:prstGeom>
+          <a:noFill/>
+          <a:ln>
+            <a:noFill/>
+          </a:ln>
+        </p:spPr>
+        <p:txBody>
+          <a:bodyPr wrap="square" lIns="182880" tIns="91440" rIns="182880" bIns="91440" anchor="t">
             <a:normAutofit/>
           </a:bodyPr>
           <a:lstStyle/>
@@ -1237,45 +1302,43 @@
               </a:spcAft>
             </a:pPr>
             <a:r>
-              <a:rPr lang="en-US" sz="1400" b="1">
-                <a:solidFill>
-                  <a:srgbClr val="8B5CF6"/>
-                </a:solidFill>
-              </a:rPr>
-              <a:t>DECISION  </a:t>
-            </a:r>
-            <a:r>
-              <a:rPr lang="en-US" sz="2000" b="1">
-                <a:solidFill>
-                  <a:srgbClr val="F7F4FF"/>
-                </a:solidFill>
-              </a:rPr>
-              <a:t>Standardize skills and MCP; govern compatibility and ownership per host.</a:t>
-            </a:r>
-          </a:p>
-        </p:txBody>
-      </p:sp>
-      <p:sp>
-        <p:nvSpPr>
-          <p:cNvPr id="6" name="Footer"/>
-          <p:cNvSpPr txBox="1"/>
-          <p:nvPr/>
-        </p:nvSpPr>
-        <p:spPr>
-          <a:xfrm>
-            <a:off x="685800" y="6250000"/>
-            <a:ext cx="9400000" cy="420000"/>
-          </a:xfrm>
-          <a:prstGeom prst="rect">
-            <a:avLst/>
-          </a:prstGeom>
-          <a:noFill/>
-          <a:ln>
-            <a:noFill/>
-          </a:ln>
-        </p:spPr>
-        <p:txBody>
-          <a:bodyPr wrap="square" lIns="182880" tIns="91440" rIns="182880" bIns="91440" anchor="t">
+              <a:rPr lang="en-US" sz="2400">
+                <a:solidFill>
+                  <a:srgbClr val="64686E"/>
+                </a:solidFill>
+              </a:rPr>
+              <a:t>Bottom line: standardize skills and MCP, then govern compatibility and ownership for each host.</a:t>
+            </a:r>
+          </a:p>
+        </p:txBody>
+      </p:sp>
+      <p:sp>
+        <p:nvSpPr>
+          <p:cNvPr id="8" name="Decision"/>
+          <p:cNvSpPr/>
+          <p:nvPr/>
+        </p:nvSpPr>
+        <p:spPr>
+          <a:xfrm>
+            <a:off x="685800" y="4650000"/>
+            <a:ext cx="10820400" cy="1000000"/>
+          </a:xfrm>
+          <a:prstGeom prst="roundRect">
+            <a:avLst>
+              <a:gd name="adj" fmla="val 6000"/>
+            </a:avLst>
+          </a:prstGeom>
+          <a:solidFill>
+            <a:srgbClr val="EDF6FC"/>
+          </a:solidFill>
+          <a:ln w="12700">
+            <a:solidFill>
+              <a:srgbClr val="567892"/>
+            </a:solidFill>
+          </a:ln>
+        </p:spPr>
+        <p:txBody>
+          <a:bodyPr wrap="square" lIns="182880" tIns="91440" rIns="182880" bIns="91440" anchor="ctr">
             <a:normAutofit/>
           </a:bodyPr>
           <a:lstStyle/>
@@ -1289,26 +1352,34 @@
               </a:spcAft>
             </a:pPr>
             <a:r>
-              <a:rPr lang="en-US" sz="1000">
-                <a:solidFill>
-                  <a:srgbClr val="B4B5C4"/>
-                </a:solidFill>
-              </a:rPr>
-              <a:t>microsoft-plugin-architecture-2026-05-am-michael-kokoro-onnx</a:t>
-            </a:r>
-          </a:p>
-        </p:txBody>
-      </p:sp>
-      <p:sp>
-        <p:nvSpPr>
-          <p:cNvPr id="7" name="Slide number"/>
-          <p:cNvSpPr txBox="1"/>
-          <p:nvPr/>
-        </p:nvSpPr>
-        <p:spPr>
-          <a:xfrm>
-            <a:off x="10100000" y="6250000"/>
-            <a:ext cx="1400000" cy="420000"/>
+              <a:rPr lang="en-US" sz="1400" b="1">
+                <a:solidFill>
+                  <a:srgbClr val="006EC3"/>
+                </a:solidFill>
+              </a:rPr>
+              <a:t>DECISION  </a:t>
+            </a:r>
+            <a:r>
+              <a:rPr lang="en-US" sz="2000" b="1">
+                <a:solidFill>
+                  <a:srgbClr val="0B121E"/>
+                </a:solidFill>
+              </a:rPr>
+              <a:t>Standardize skills and MCP; govern compatibility and ownership per host.</a:t>
+            </a:r>
+          </a:p>
+        </p:txBody>
+      </p:sp>
+      <p:sp>
+        <p:nvSpPr>
+          <p:cNvPr id="9" name="Footer"/>
+          <p:cNvSpPr txBox="1"/>
+          <p:nvPr/>
+        </p:nvSpPr>
+        <p:spPr>
+          <a:xfrm>
+            <a:off x="685800" y="6250000"/>
+            <a:ext cx="10820400" cy="420000"/>
           </a:xfrm>
           <a:prstGeom prst="rect">
             <a:avLst/>
@@ -1324,14 +1395,21 @@
           </a:bodyPr>
           <a:lstStyle/>
           <a:p>
-            <a:pPr algn="r"/>
+            <a:pPr algn="l">
+              <a:lnSpc>
+                <a:spcPct val="105000"/>
+              </a:lnSpc>
+              <a:spcAft>
+                <a:spcPts val="0"/>
+              </a:spcAft>
+            </a:pPr>
             <a:r>
               <a:rPr lang="en-US" sz="1000">
                 <a:solidFill>
-                  <a:srgbClr val="B4B5C4"/>
-                </a:solidFill>
-              </a:rPr>
-              <a:t>1 / 6</a:t>
+                  <a:srgbClr val="64686E"/>
+                </a:solidFill>
+              </a:rPr>
+              <a:t>microsoft-plugin-architecture-2026-06-am-michael-kokoro-onnx</a:t>
             </a:r>
           </a:p>
         </p:txBody>
@@ -1350,7 +1428,7 @@
     <p:bg>
       <p:bgPr>
         <a:solidFill>
-          <a:srgbClr val="08142D"/>
+          <a:srgbClr val="F4F8FC"/>
         </a:solidFill>
         <a:effectLst/>
       </p:bgPr>
@@ -1364,20 +1442,20 @@
       <p:grpSpPr/>
       <p:sp>
         <p:nvSpPr>
-          <p:cNvPr id="2" name="Accent band"/>
+          <p:cNvPr id="2" name="Brand band"/>
           <p:cNvSpPr/>
           <p:nvPr/>
         </p:nvSpPr>
         <p:spPr>
           <a:xfrm>
             <a:off x="0" y="0"/>
-            <a:ext cx="12192000" cy="91440"/>
+            <a:ext cx="12192000" cy="502920"/>
           </a:xfrm>
           <a:prstGeom prst="rect">
             <a:avLst/>
           </a:prstGeom>
           <a:solidFill>
-            <a:srgbClr val="8B5CF6"/>
+            <a:srgbClr val="0E1726"/>
           </a:solidFill>
           <a:ln>
             <a:noFill/>
@@ -1386,14 +1464,36 @@
       </p:sp>
       <p:sp>
         <p:nvSpPr>
-          <p:cNvPr id="3" name="Title"/>
-          <p:cNvSpPr txBox="1"/>
-          <p:nvPr/>
-        </p:nvSpPr>
-        <p:spPr>
-          <a:xfrm>
-            <a:off x="685800" y="420000"/>
-            <a:ext cx="10820400" cy="1150000"/>
+          <p:cNvPr id="3" name="Highlight rule"/>
+          <p:cNvSpPr/>
+          <p:nvPr/>
+        </p:nvSpPr>
+        <p:spPr>
+          <a:xfrm>
+            <a:off x="0" y="502920"/>
+            <a:ext cx="12192000" cy="45720"/>
+          </a:xfrm>
+          <a:prstGeom prst="rect">
+            <a:avLst/>
+          </a:prstGeom>
+          <a:solidFill>
+            <a:srgbClr val="8AC1EB"/>
+          </a:solidFill>
+          <a:ln>
+            <a:noFill/>
+          </a:ln>
+        </p:spPr>
+      </p:sp>
+      <p:sp>
+        <p:nvSpPr>
+          <p:cNvPr id="4" name="Deck kicker"/>
+          <p:cNvSpPr txBox="1"/>
+          <p:nvPr/>
+        </p:nvSpPr>
+        <p:spPr>
+          <a:xfrm>
+            <a:off x="685800" y="0"/>
+            <a:ext cx="8400000" cy="502920"/>
           </a:xfrm>
           <a:prstGeom prst="rect">
             <a:avLst/>
@@ -1418,45 +1518,74 @@
               </a:spcAft>
             </a:pPr>
             <a:r>
-              <a:rPr lang="en-US" sz="2900" b="1">
-                <a:solidFill>
-                  <a:srgbClr val="F7F4FF"/>
-                </a:solidFill>
-              </a:rPr>
-              <a:t>1.</a:t>
-            </a:r>
-            <a:r>
-              <a:rPr lang="en-US" sz="2900" b="1">
-                <a:solidFill>
-                  <a:srgbClr val="8B5CF6"/>
-                </a:solidFill>
-              </a:rPr>
-              <a:t> Choose the host route</a:t>
-            </a:r>
-          </a:p>
-        </p:txBody>
-      </p:sp>
-      <p:sp>
-        <p:nvSpPr>
-          <p:cNvPr id="4" name="Body"/>
-          <p:cNvSpPr txBox="1"/>
-          <p:nvPr/>
-        </p:nvSpPr>
-        <p:spPr>
-          <a:xfrm>
-            <a:off x="685800" y="1750000"/>
-            <a:ext cx="3900000" cy="3900000"/>
-          </a:xfrm>
-          <a:prstGeom prst="rect">
-            <a:avLst/>
-          </a:prstGeom>
-          <a:noFill/>
-          <a:ln>
-            <a:noFill/>
-          </a:ln>
-        </p:spPr>
-        <p:txBody>
-          <a:bodyPr wrap="square" lIns="182880" tIns="91440" rIns="182880" bIns="91440" anchor="t">
+              <a:rPr lang="en-US" sz="1100" b="1" cap="all" spc="120">
+                <a:solidFill>
+                  <a:srgbClr val="FFFFFF"/>
+                </a:solidFill>
+              </a:rPr>
+              <a:t>Microsoft Plugin Architecture</a:t>
+            </a:r>
+          </a:p>
+        </p:txBody>
+      </p:sp>
+      <p:sp>
+        <p:nvSpPr>
+          <p:cNvPr id="5" name="Slide number"/>
+          <p:cNvSpPr txBox="1"/>
+          <p:nvPr/>
+        </p:nvSpPr>
+        <p:spPr>
+          <a:xfrm>
+            <a:off x="9100000" y="0"/>
+            <a:ext cx="2406400" cy="502920"/>
+          </a:xfrm>
+          <a:prstGeom prst="rect">
+            <a:avLst/>
+          </a:prstGeom>
+          <a:noFill/>
+          <a:ln>
+            <a:noFill/>
+          </a:ln>
+        </p:spPr>
+        <p:txBody>
+          <a:bodyPr wrap="square" lIns="182880" tIns="91440" rIns="182880" bIns="91440" anchor="ctr">
+            <a:normAutofit/>
+          </a:bodyPr>
+          <a:lstStyle/>
+          <a:p>
+            <a:pPr algn="r"/>
+            <a:r>
+              <a:rPr lang="en-US" sz="1100" b="1" cap="all" spc="120">
+                <a:solidFill>
+                  <a:srgbClr val="BCBEC2"/>
+                </a:solidFill>
+              </a:rPr>
+              <a:t>2 / 6</a:t>
+            </a:r>
+          </a:p>
+        </p:txBody>
+      </p:sp>
+      <p:sp>
+        <p:nvSpPr>
+          <p:cNvPr id="6" name="Title"/>
+          <p:cNvSpPr txBox="1"/>
+          <p:nvPr/>
+        </p:nvSpPr>
+        <p:spPr>
+          <a:xfrm>
+            <a:off x="685800" y="700000"/>
+            <a:ext cx="10820400" cy="1150000"/>
+          </a:xfrm>
+          <a:prstGeom prst="rect">
+            <a:avLst/>
+          </a:prstGeom>
+          <a:noFill/>
+          <a:ln>
+            <a:noFill/>
+          </a:ln>
+        </p:spPr>
+        <p:txBody>
+          <a:bodyPr wrap="square" lIns="182880" tIns="91440" rIns="182880" bIns="91440" anchor="ctr">
             <a:normAutofit/>
           </a:bodyPr>
           <a:lstStyle/>
@@ -1470,77 +1599,36 @@
               </a:spcAft>
             </a:pPr>
             <a:r>
-              <a:rPr lang="en-US" sz="2400">
-                <a:solidFill>
-                  <a:srgbClr val="F7F4FF"/>
-                </a:solidFill>
-              </a:rPr>
-              <a:t>Cowork uses a Microsoft 365 app package. Declarative agents use MCP or REST API actions. GitHub Copilot uses plugin packages with portable and client-specific parts.</a:t>
-            </a:r>
-          </a:p>
-        </p:txBody>
-      </p:sp>
-      <p:sp>
-        <p:nvSpPr>
-          <p:cNvPr id="5" name="Accent rule"/>
-          <p:cNvSpPr/>
-          <p:nvPr/>
-        </p:nvSpPr>
-        <p:spPr>
-          <a:xfrm>
-            <a:off x="548640" y="1800000"/>
-            <a:ext cx="45720" cy="3800000"/>
-          </a:xfrm>
-          <a:prstGeom prst="rect">
-            <a:avLst/>
-          </a:prstGeom>
-          <a:solidFill>
-            <a:srgbClr val="8B5CF6"/>
-          </a:solidFill>
-          <a:ln>
-            <a:noFill/>
-          </a:ln>
-        </p:spPr>
-      </p:sp>
-      <p:pic>
-        <p:nvPicPr>
-          <p:cNvPr id="6" name="Asset visual-three-routes" descr="Three host routes share concepts, but each has a distinct delivery contract. (mermaid diagram)"/>
-          <p:cNvPicPr>
-            <a:picLocks noChangeAspect="1"/>
-          </p:cNvPicPr>
-          <p:nvPr/>
-        </p:nvPicPr>
-        <p:blipFill>
-          <a:blip r:embed="rIdImage1"/>
-          <a:stretch>
-            <a:fillRect/>
-          </a:stretch>
-        </p:blipFill>
-        <p:spPr>
-          <a:xfrm>
-            <a:off x="5000000" y="2021875"/>
-            <a:ext cx="6500000" cy="3656250"/>
-          </a:xfrm>
-          <a:prstGeom prst="rect">
-            <a:avLst/>
-          </a:prstGeom>
-          <a:ln>
-            <a:solidFill>
-              <a:srgbClr val="D9D9D9"/>
-            </a:solidFill>
-          </a:ln>
-        </p:spPr>
-      </p:pic>
-      <p:sp>
-        <p:nvSpPr>
-          <p:cNvPr id="7" name="Footer"/>
-          <p:cNvSpPr txBox="1"/>
-          <p:nvPr/>
-        </p:nvSpPr>
-        <p:spPr>
-          <a:xfrm>
-            <a:off x="685800" y="6250000"/>
-            <a:ext cx="9400000" cy="420000"/>
+              <a:rPr lang="en-US" sz="2900" b="1">
+                <a:solidFill>
+                  <a:srgbClr val="0B121E"/>
+                </a:solidFill>
+                <a:latin typeface="+mj-lt"/>
+              </a:rPr>
+              <a:t>1.</a:t>
+            </a:r>
+            <a:r>
+              <a:rPr lang="en-US" sz="2900" b="1">
+                <a:solidFill>
+                  <a:srgbClr val="006EC3"/>
+                </a:solidFill>
+                <a:latin typeface="+mj-lt"/>
+              </a:rPr>
+              <a:t> Choose the host route</a:t>
+            </a:r>
+          </a:p>
+        </p:txBody>
+      </p:sp>
+      <p:sp>
+        <p:nvSpPr>
+          <p:cNvPr id="7" name="Body"/>
+          <p:cNvSpPr txBox="1"/>
+          <p:nvPr/>
+        </p:nvSpPr>
+        <p:spPr>
+          <a:xfrm>
+            <a:off x="685800" y="1950000"/>
+            <a:ext cx="3900000" cy="3900000"/>
           </a:xfrm>
           <a:prstGeom prst="rect">
             <a:avLst/>
@@ -1565,26 +1653,77 @@
               </a:spcAft>
             </a:pPr>
             <a:r>
-              <a:rPr lang="en-US" sz="1000">
-                <a:solidFill>
-                  <a:srgbClr val="B4B5C4"/>
-                </a:solidFill>
-              </a:rPr>
-              <a:t>Sources: Build plugins for Copilot Cowork  ·  MCP and API plugins for declarative agents  ·  About GitHub Copilot plugins</a:t>
-            </a:r>
-          </a:p>
-        </p:txBody>
-      </p:sp>
-      <p:sp>
-        <p:nvSpPr>
-          <p:cNvPr id="8" name="Slide number"/>
-          <p:cNvSpPr txBox="1"/>
-          <p:nvPr/>
-        </p:nvSpPr>
-        <p:spPr>
-          <a:xfrm>
-            <a:off x="10100000" y="6250000"/>
-            <a:ext cx="1400000" cy="420000"/>
+              <a:rPr lang="en-US" sz="2400">
+                <a:solidFill>
+                  <a:srgbClr val="0B121E"/>
+                </a:solidFill>
+              </a:rPr>
+              <a:t>Cowork uses a Microsoft 365 app package. Declarative agents use MCP or REST API actions. GitHub Copilot uses plugin packages with portable and client-specific parts.</a:t>
+            </a:r>
+          </a:p>
+        </p:txBody>
+      </p:sp>
+      <p:sp>
+        <p:nvSpPr>
+          <p:cNvPr id="8" name="Accent rule"/>
+          <p:cNvSpPr/>
+          <p:nvPr/>
+        </p:nvSpPr>
+        <p:spPr>
+          <a:xfrm>
+            <a:off x="548640" y="2000000"/>
+            <a:ext cx="45720" cy="3800000"/>
+          </a:xfrm>
+          <a:prstGeom prst="rect">
+            <a:avLst/>
+          </a:prstGeom>
+          <a:solidFill>
+            <a:srgbClr val="006EC3"/>
+          </a:solidFill>
+          <a:ln>
+            <a:noFill/>
+          </a:ln>
+        </p:spPr>
+      </p:sp>
+      <p:pic>
+        <p:nvPicPr>
+          <p:cNvPr id="9" name="Asset visual-three-routes" descr="Three host routes share concepts, but each has a distinct delivery contract. (mermaid diagram)"/>
+          <p:cNvPicPr>
+            <a:picLocks noChangeAspect="1"/>
+          </p:cNvPicPr>
+          <p:nvPr/>
+        </p:nvPicPr>
+        <p:blipFill>
+          <a:blip r:embed="rIdImage1"/>
+          <a:stretch>
+            <a:fillRect/>
+          </a:stretch>
+        </p:blipFill>
+        <p:spPr>
+          <a:xfrm>
+            <a:off x="5000000" y="2221875"/>
+            <a:ext cx="6500000" cy="3656250"/>
+          </a:xfrm>
+          <a:prstGeom prst="rect">
+            <a:avLst/>
+          </a:prstGeom>
+          <a:ln>
+            <a:solidFill>
+              <a:srgbClr val="D9D9D9"/>
+            </a:solidFill>
+          </a:ln>
+        </p:spPr>
+      </p:pic>
+      <p:sp>
+        <p:nvSpPr>
+          <p:cNvPr id="10" name="Footer"/>
+          <p:cNvSpPr txBox="1"/>
+          <p:nvPr/>
+        </p:nvSpPr>
+        <p:spPr>
+          <a:xfrm>
+            <a:off x="685800" y="6250000"/>
+            <a:ext cx="10820400" cy="420000"/>
           </a:xfrm>
           <a:prstGeom prst="rect">
             <a:avLst/>
@@ -1600,14 +1739,21 @@
           </a:bodyPr>
           <a:lstStyle/>
           <a:p>
-            <a:pPr algn="r"/>
+            <a:pPr algn="l">
+              <a:lnSpc>
+                <a:spcPct val="105000"/>
+              </a:lnSpc>
+              <a:spcAft>
+                <a:spcPts val="0"/>
+              </a:spcAft>
+            </a:pPr>
             <a:r>
               <a:rPr lang="en-US" sz="1000">
                 <a:solidFill>
-                  <a:srgbClr val="B4B5C4"/>
-                </a:solidFill>
-              </a:rPr>
-              <a:t>2 / 6</a:t>
+                  <a:srgbClr val="64686E"/>
+                </a:solidFill>
+              </a:rPr>
+              <a:t>Sources: Build plugins for Copilot Cowork  ·  MCP and API plugins for declarative agents  ·  About GitHub Copilot plugins</a:t>
             </a:r>
           </a:p>
         </p:txBody>
@@ -1626,7 +1772,7 @@
     <p:bg>
       <p:bgPr>
         <a:solidFill>
-          <a:srgbClr val="08142D"/>
+          <a:srgbClr val="F4F8FC"/>
         </a:solidFill>
         <a:effectLst/>
       </p:bgPr>
@@ -1640,20 +1786,20 @@
       <p:grpSpPr/>
       <p:sp>
         <p:nvSpPr>
-          <p:cNvPr id="2" name="Accent band"/>
+          <p:cNvPr id="2" name="Brand band"/>
           <p:cNvSpPr/>
           <p:nvPr/>
         </p:nvSpPr>
         <p:spPr>
           <a:xfrm>
             <a:off x="0" y="0"/>
-            <a:ext cx="12192000" cy="91440"/>
+            <a:ext cx="12192000" cy="502920"/>
           </a:xfrm>
           <a:prstGeom prst="rect">
             <a:avLst/>
           </a:prstGeom>
           <a:solidFill>
-            <a:srgbClr val="8B5CF6"/>
+            <a:srgbClr val="0E1726"/>
           </a:solidFill>
           <a:ln>
             <a:noFill/>
@@ -1662,14 +1808,36 @@
       </p:sp>
       <p:sp>
         <p:nvSpPr>
-          <p:cNvPr id="3" name="Title"/>
-          <p:cNvSpPr txBox="1"/>
-          <p:nvPr/>
-        </p:nvSpPr>
-        <p:spPr>
-          <a:xfrm>
-            <a:off x="685800" y="420000"/>
-            <a:ext cx="10820400" cy="1150000"/>
+          <p:cNvPr id="3" name="Highlight rule"/>
+          <p:cNvSpPr/>
+          <p:nvPr/>
+        </p:nvSpPr>
+        <p:spPr>
+          <a:xfrm>
+            <a:off x="0" y="502920"/>
+            <a:ext cx="12192000" cy="45720"/>
+          </a:xfrm>
+          <a:prstGeom prst="rect">
+            <a:avLst/>
+          </a:prstGeom>
+          <a:solidFill>
+            <a:srgbClr val="8AC1EB"/>
+          </a:solidFill>
+          <a:ln>
+            <a:noFill/>
+          </a:ln>
+        </p:spPr>
+      </p:sp>
+      <p:sp>
+        <p:nvSpPr>
+          <p:cNvPr id="4" name="Deck kicker"/>
+          <p:cNvSpPr txBox="1"/>
+          <p:nvPr/>
+        </p:nvSpPr>
+        <p:spPr>
+          <a:xfrm>
+            <a:off x="685800" y="0"/>
+            <a:ext cx="8400000" cy="502920"/>
           </a:xfrm>
           <a:prstGeom prst="rect">
             <a:avLst/>
@@ -1694,45 +1862,74 @@
               </a:spcAft>
             </a:pPr>
             <a:r>
-              <a:rPr lang="en-US" sz="2900" b="1">
-                <a:solidFill>
-                  <a:srgbClr val="F7F4FF"/>
-                </a:solidFill>
-              </a:rPr>
-              <a:t>2.</a:t>
-            </a:r>
-            <a:r>
-              <a:rPr lang="en-US" sz="2900" b="1">
-                <a:solidFill>
-                  <a:srgbClr val="8B5CF6"/>
-                </a:solidFill>
-              </a:rPr>
-              <a:t> Reuse the core, not the wrapper</a:t>
-            </a:r>
-          </a:p>
-        </p:txBody>
-      </p:sp>
-      <p:sp>
-        <p:nvSpPr>
-          <p:cNvPr id="4" name="Body"/>
-          <p:cNvSpPr txBox="1"/>
-          <p:nvPr/>
-        </p:nvSpPr>
-        <p:spPr>
-          <a:xfrm>
-            <a:off x="685800" y="1750000"/>
-            <a:ext cx="3900000" cy="3900000"/>
-          </a:xfrm>
-          <a:prstGeom prst="rect">
-            <a:avLst/>
-          </a:prstGeom>
-          <a:noFill/>
-          <a:ln>
-            <a:noFill/>
-          </a:ln>
-        </p:spPr>
-        <p:txBody>
-          <a:bodyPr wrap="square" lIns="182880" tIns="91440" rIns="182880" bIns="91440" anchor="t">
+              <a:rPr lang="en-US" sz="1100" b="1" cap="all" spc="120">
+                <a:solidFill>
+                  <a:srgbClr val="FFFFFF"/>
+                </a:solidFill>
+              </a:rPr>
+              <a:t>Microsoft Plugin Architecture</a:t>
+            </a:r>
+          </a:p>
+        </p:txBody>
+      </p:sp>
+      <p:sp>
+        <p:nvSpPr>
+          <p:cNvPr id="5" name="Slide number"/>
+          <p:cNvSpPr txBox="1"/>
+          <p:nvPr/>
+        </p:nvSpPr>
+        <p:spPr>
+          <a:xfrm>
+            <a:off x="9100000" y="0"/>
+            <a:ext cx="2406400" cy="502920"/>
+          </a:xfrm>
+          <a:prstGeom prst="rect">
+            <a:avLst/>
+          </a:prstGeom>
+          <a:noFill/>
+          <a:ln>
+            <a:noFill/>
+          </a:ln>
+        </p:spPr>
+        <p:txBody>
+          <a:bodyPr wrap="square" lIns="182880" tIns="91440" rIns="182880" bIns="91440" anchor="ctr">
+            <a:normAutofit/>
+          </a:bodyPr>
+          <a:lstStyle/>
+          <a:p>
+            <a:pPr algn="r"/>
+            <a:r>
+              <a:rPr lang="en-US" sz="1100" b="1" cap="all" spc="120">
+                <a:solidFill>
+                  <a:srgbClr val="BCBEC2"/>
+                </a:solidFill>
+              </a:rPr>
+              <a:t>3 / 6</a:t>
+            </a:r>
+          </a:p>
+        </p:txBody>
+      </p:sp>
+      <p:sp>
+        <p:nvSpPr>
+          <p:cNvPr id="6" name="Title"/>
+          <p:cNvSpPr txBox="1"/>
+          <p:nvPr/>
+        </p:nvSpPr>
+        <p:spPr>
+          <a:xfrm>
+            <a:off x="685800" y="700000"/>
+            <a:ext cx="10820400" cy="1150000"/>
+          </a:xfrm>
+          <a:prstGeom prst="rect">
+            <a:avLst/>
+          </a:prstGeom>
+          <a:noFill/>
+          <a:ln>
+            <a:noFill/>
+          </a:ln>
+        </p:spPr>
+        <p:txBody>
+          <a:bodyPr wrap="square" lIns="182880" tIns="91440" rIns="182880" bIns="91440" anchor="ctr">
             <a:normAutofit/>
           </a:bodyPr>
           <a:lstStyle/>
@@ -1746,77 +1943,36 @@
               </a:spcAft>
             </a:pPr>
             <a:r>
-              <a:rPr lang="en-US" sz="2500">
-                <a:solidFill>
-                  <a:srgbClr val="F7F4FF"/>
-                </a:solidFill>
-              </a:rPr>
-              <a:t>Reuse skill logic and MCP configuration where tested. Keep authentication, manifests, discovery and client-only components inside each host package.</a:t>
-            </a:r>
-          </a:p>
-        </p:txBody>
-      </p:sp>
-      <p:sp>
-        <p:nvSpPr>
-          <p:cNvPr id="5" name="Accent rule"/>
-          <p:cNvSpPr/>
-          <p:nvPr/>
-        </p:nvSpPr>
-        <p:spPr>
-          <a:xfrm>
-            <a:off x="548640" y="1800000"/>
-            <a:ext cx="45720" cy="3800000"/>
-          </a:xfrm>
-          <a:prstGeom prst="rect">
-            <a:avLst/>
-          </a:prstGeom>
-          <a:solidFill>
-            <a:srgbClr val="8B5CF6"/>
-          </a:solidFill>
-          <a:ln>
-            <a:noFill/>
-          </a:ln>
-        </p:spPr>
-      </p:sp>
-      <p:pic>
-        <p:nvPicPr>
-          <p:cNvPr id="6" name="Asset visual-reuse-boundary" descr="A governed reusable core connects skills to tools and data while host wrappers own policy and packaging. (excalidraw diagram)"/>
-          <p:cNvPicPr>
-            <a:picLocks noChangeAspect="1"/>
-          </p:cNvPicPr>
-          <p:nvPr/>
-        </p:nvPicPr>
-        <p:blipFill>
-          <a:blip r:embed="rIdImage1"/>
-          <a:stretch>
-            <a:fillRect/>
-          </a:stretch>
-        </p:blipFill>
-        <p:spPr>
-          <a:xfrm>
-            <a:off x="5000000" y="2021875"/>
-            <a:ext cx="6500000" cy="3656250"/>
-          </a:xfrm>
-          <a:prstGeom prst="rect">
-            <a:avLst/>
-          </a:prstGeom>
-          <a:ln>
-            <a:solidFill>
-              <a:srgbClr val="D9D9D9"/>
-            </a:solidFill>
-          </a:ln>
-        </p:spPr>
-      </p:pic>
-      <p:sp>
-        <p:nvSpPr>
-          <p:cNvPr id="7" name="Footer"/>
-          <p:cNvSpPr txBox="1"/>
-          <p:nvPr/>
-        </p:nvSpPr>
-        <p:spPr>
-          <a:xfrm>
-            <a:off x="685800" y="6250000"/>
-            <a:ext cx="9400000" cy="420000"/>
+              <a:rPr lang="en-US" sz="2900" b="1">
+                <a:solidFill>
+                  <a:srgbClr val="0B121E"/>
+                </a:solidFill>
+                <a:latin typeface="+mj-lt"/>
+              </a:rPr>
+              <a:t>2.</a:t>
+            </a:r>
+            <a:r>
+              <a:rPr lang="en-US" sz="2900" b="1">
+                <a:solidFill>
+                  <a:srgbClr val="006EC3"/>
+                </a:solidFill>
+                <a:latin typeface="+mj-lt"/>
+              </a:rPr>
+              <a:t> Reuse the core, not the wrapper</a:t>
+            </a:r>
+          </a:p>
+        </p:txBody>
+      </p:sp>
+      <p:sp>
+        <p:nvSpPr>
+          <p:cNvPr id="7" name="Body"/>
+          <p:cNvSpPr txBox="1"/>
+          <p:nvPr/>
+        </p:nvSpPr>
+        <p:spPr>
+          <a:xfrm>
+            <a:off x="685800" y="1950000"/>
+            <a:ext cx="3900000" cy="3900000"/>
           </a:xfrm>
           <a:prstGeom prst="rect">
             <a:avLst/>
@@ -1841,26 +1997,77 @@
               </a:spcAft>
             </a:pPr>
             <a:r>
-              <a:rPr lang="en-US" sz="1000">
-                <a:solidFill>
-                  <a:srgbClr val="B4B5C4"/>
-                </a:solidFill>
-              </a:rPr>
-              <a:t>Sources: Build plugins for Copilot Cowork  ·  About GitHub Copilot plugins</a:t>
-            </a:r>
-          </a:p>
-        </p:txBody>
-      </p:sp>
-      <p:sp>
-        <p:nvSpPr>
-          <p:cNvPr id="8" name="Slide number"/>
-          <p:cNvSpPr txBox="1"/>
-          <p:nvPr/>
-        </p:nvSpPr>
-        <p:spPr>
-          <a:xfrm>
-            <a:off x="10100000" y="6250000"/>
-            <a:ext cx="1400000" cy="420000"/>
+              <a:rPr lang="en-US" sz="2500">
+                <a:solidFill>
+                  <a:srgbClr val="0B121E"/>
+                </a:solidFill>
+              </a:rPr>
+              <a:t>Reuse skill logic and MCP configuration where tested. Keep authentication, manifests, discovery and client-only components inside each host package.</a:t>
+            </a:r>
+          </a:p>
+        </p:txBody>
+      </p:sp>
+      <p:sp>
+        <p:nvSpPr>
+          <p:cNvPr id="8" name="Accent rule"/>
+          <p:cNvSpPr/>
+          <p:nvPr/>
+        </p:nvSpPr>
+        <p:spPr>
+          <a:xfrm>
+            <a:off x="548640" y="2000000"/>
+            <a:ext cx="45720" cy="3800000"/>
+          </a:xfrm>
+          <a:prstGeom prst="rect">
+            <a:avLst/>
+          </a:prstGeom>
+          <a:solidFill>
+            <a:srgbClr val="006EC3"/>
+          </a:solidFill>
+          <a:ln>
+            <a:noFill/>
+          </a:ln>
+        </p:spPr>
+      </p:sp>
+      <p:pic>
+        <p:nvPicPr>
+          <p:cNvPr id="9" name="Asset visual-reuse-boundary" descr="A governed reusable core connects skills to tools and data while host wrappers own policy and packaging. (excalidraw diagram)"/>
+          <p:cNvPicPr>
+            <a:picLocks noChangeAspect="1"/>
+          </p:cNvPicPr>
+          <p:nvPr/>
+        </p:nvPicPr>
+        <p:blipFill>
+          <a:blip r:embed="rIdImage1"/>
+          <a:stretch>
+            <a:fillRect/>
+          </a:stretch>
+        </p:blipFill>
+        <p:spPr>
+          <a:xfrm>
+            <a:off x="5000000" y="2221875"/>
+            <a:ext cx="6500000" cy="3656250"/>
+          </a:xfrm>
+          <a:prstGeom prst="rect">
+            <a:avLst/>
+          </a:prstGeom>
+          <a:ln>
+            <a:solidFill>
+              <a:srgbClr val="D9D9D9"/>
+            </a:solidFill>
+          </a:ln>
+        </p:spPr>
+      </p:pic>
+      <p:sp>
+        <p:nvSpPr>
+          <p:cNvPr id="10" name="Footer"/>
+          <p:cNvSpPr txBox="1"/>
+          <p:nvPr/>
+        </p:nvSpPr>
+        <p:spPr>
+          <a:xfrm>
+            <a:off x="685800" y="6250000"/>
+            <a:ext cx="10820400" cy="420000"/>
           </a:xfrm>
           <a:prstGeom prst="rect">
             <a:avLst/>
@@ -1876,14 +2083,21 @@
           </a:bodyPr>
           <a:lstStyle/>
           <a:p>
-            <a:pPr algn="r"/>
+            <a:pPr algn="l">
+              <a:lnSpc>
+                <a:spcPct val="105000"/>
+              </a:lnSpc>
+              <a:spcAft>
+                <a:spcPts val="0"/>
+              </a:spcAft>
+            </a:pPr>
             <a:r>
               <a:rPr lang="en-US" sz="1000">
                 <a:solidFill>
-                  <a:srgbClr val="B4B5C4"/>
-                </a:solidFill>
-              </a:rPr>
-              <a:t>3 / 6</a:t>
+                  <a:srgbClr val="64686E"/>
+                </a:solidFill>
+              </a:rPr>
+              <a:t>Sources: Build plugins for Copilot Cowork  ·  About GitHub Copilot plugins</a:t>
             </a:r>
           </a:p>
         </p:txBody>
@@ -1902,7 +2116,7 @@
     <p:bg>
       <p:bgPr>
         <a:solidFill>
-          <a:srgbClr val="08142D"/>
+          <a:srgbClr val="F4F8FC"/>
         </a:solidFill>
         <a:effectLst/>
       </p:bgPr>
@@ -1916,20 +2130,20 @@
       <p:grpSpPr/>
       <p:sp>
         <p:nvSpPr>
-          <p:cNvPr id="2" name="Accent band"/>
+          <p:cNvPr id="2" name="Brand band"/>
           <p:cNvSpPr/>
           <p:nvPr/>
         </p:nvSpPr>
         <p:spPr>
           <a:xfrm>
             <a:off x="0" y="0"/>
-            <a:ext cx="12192000" cy="91440"/>
+            <a:ext cx="12192000" cy="502920"/>
           </a:xfrm>
           <a:prstGeom prst="rect">
             <a:avLst/>
           </a:prstGeom>
           <a:solidFill>
-            <a:srgbClr val="8B5CF6"/>
+            <a:srgbClr val="0E1726"/>
           </a:solidFill>
           <a:ln>
             <a:noFill/>
@@ -1938,14 +2152,36 @@
       </p:sp>
       <p:sp>
         <p:nvSpPr>
-          <p:cNvPr id="3" name="Title"/>
-          <p:cNvSpPr txBox="1"/>
-          <p:nvPr/>
-        </p:nvSpPr>
-        <p:spPr>
-          <a:xfrm>
-            <a:off x="685800" y="420000"/>
-            <a:ext cx="10820400" cy="1150000"/>
+          <p:cNvPr id="3" name="Highlight rule"/>
+          <p:cNvSpPr/>
+          <p:nvPr/>
+        </p:nvSpPr>
+        <p:spPr>
+          <a:xfrm>
+            <a:off x="0" y="502920"/>
+            <a:ext cx="12192000" cy="45720"/>
+          </a:xfrm>
+          <a:prstGeom prst="rect">
+            <a:avLst/>
+          </a:prstGeom>
+          <a:solidFill>
+            <a:srgbClr val="8AC1EB"/>
+          </a:solidFill>
+          <a:ln>
+            <a:noFill/>
+          </a:ln>
+        </p:spPr>
+      </p:sp>
+      <p:sp>
+        <p:nvSpPr>
+          <p:cNvPr id="4" name="Deck kicker"/>
+          <p:cNvSpPr txBox="1"/>
+          <p:nvPr/>
+        </p:nvSpPr>
+        <p:spPr>
+          <a:xfrm>
+            <a:off x="685800" y="0"/>
+            <a:ext cx="8400000" cy="502920"/>
           </a:xfrm>
           <a:prstGeom prst="rect">
             <a:avLst/>
@@ -1970,45 +2206,74 @@
               </a:spcAft>
             </a:pPr>
             <a:r>
-              <a:rPr lang="en-US" sz="2900" b="1">
-                <a:solidFill>
-                  <a:srgbClr val="F7F4FF"/>
-                </a:solidFill>
-              </a:rPr>
-              <a:t>3.</a:t>
-            </a:r>
-            <a:r>
-              <a:rPr lang="en-US" sz="2900" b="1">
-                <a:solidFill>
-                  <a:srgbClr val="8B5CF6"/>
-                </a:solidFill>
-              </a:rPr>
-              <a:t> Preserve supported paths</a:t>
-            </a:r>
-          </a:p>
-        </p:txBody>
-      </p:sp>
-      <p:sp>
-        <p:nvSpPr>
-          <p:cNvPr id="4" name="Body"/>
-          <p:cNvSpPr txBox="1"/>
-          <p:nvPr/>
-        </p:nvSpPr>
-        <p:spPr>
-          <a:xfrm>
-            <a:off x="685800" y="1750000"/>
-            <a:ext cx="3900000" cy="3900000"/>
-          </a:xfrm>
-          <a:prstGeom prst="rect">
-            <a:avLst/>
-          </a:prstGeom>
-          <a:noFill/>
-          <a:ln>
-            <a:noFill/>
-          </a:ln>
-        </p:spPr>
-        <p:txBody>
-          <a:bodyPr wrap="square" lIns="182880" tIns="91440" rIns="182880" bIns="91440" anchor="t">
+              <a:rPr lang="en-US" sz="1100" b="1" cap="all" spc="120">
+                <a:solidFill>
+                  <a:srgbClr val="FFFFFF"/>
+                </a:solidFill>
+              </a:rPr>
+              <a:t>Microsoft Plugin Architecture</a:t>
+            </a:r>
+          </a:p>
+        </p:txBody>
+      </p:sp>
+      <p:sp>
+        <p:nvSpPr>
+          <p:cNvPr id="5" name="Slide number"/>
+          <p:cNvSpPr txBox="1"/>
+          <p:nvPr/>
+        </p:nvSpPr>
+        <p:spPr>
+          <a:xfrm>
+            <a:off x="9100000" y="0"/>
+            <a:ext cx="2406400" cy="502920"/>
+          </a:xfrm>
+          <a:prstGeom prst="rect">
+            <a:avLst/>
+          </a:prstGeom>
+          <a:noFill/>
+          <a:ln>
+            <a:noFill/>
+          </a:ln>
+        </p:spPr>
+        <p:txBody>
+          <a:bodyPr wrap="square" lIns="182880" tIns="91440" rIns="182880" bIns="91440" anchor="ctr">
+            <a:normAutofit/>
+          </a:bodyPr>
+          <a:lstStyle/>
+          <a:p>
+            <a:pPr algn="r"/>
+            <a:r>
+              <a:rPr lang="en-US" sz="1100" b="1" cap="all" spc="120">
+                <a:solidFill>
+                  <a:srgbClr val="BCBEC2"/>
+                </a:solidFill>
+              </a:rPr>
+              <a:t>4 / 6</a:t>
+            </a:r>
+          </a:p>
+        </p:txBody>
+      </p:sp>
+      <p:sp>
+        <p:nvSpPr>
+          <p:cNvPr id="6" name="Title"/>
+          <p:cNvSpPr txBox="1"/>
+          <p:nvPr/>
+        </p:nvSpPr>
+        <p:spPr>
+          <a:xfrm>
+            <a:off x="685800" y="700000"/>
+            <a:ext cx="10820400" cy="1150000"/>
+          </a:xfrm>
+          <a:prstGeom prst="rect">
+            <a:avLst/>
+          </a:prstGeom>
+          <a:noFill/>
+          <a:ln>
+            <a:noFill/>
+          </a:ln>
+        </p:spPr>
+        <p:txBody>
+          <a:bodyPr wrap="square" lIns="182880" tIns="91440" rIns="182880" bIns="91440" anchor="ctr">
             <a:normAutofit/>
           </a:bodyPr>
           <a:lstStyle/>
@@ -2022,77 +2287,36 @@
               </a:spcAft>
             </a:pPr>
             <a:r>
-              <a:rPr lang="en-US" sz="2500">
-                <a:solidFill>
-                  <a:srgbClr val="F7F4FF"/>
-                </a:solidFill>
-              </a:rPr>
-              <a:t>REST API actions remain supported in declarative agents. Agent Plugins 1.0 adds portability, while legacy GitHub Copilot plugins continue to load.</a:t>
-            </a:r>
-          </a:p>
-        </p:txBody>
-      </p:sp>
-      <p:sp>
-        <p:nvSpPr>
-          <p:cNvPr id="5" name="Accent rule"/>
-          <p:cNvSpPr/>
-          <p:nvPr/>
-        </p:nvSpPr>
-        <p:spPr>
-          <a:xfrm>
-            <a:off x="548640" y="1800000"/>
-            <a:ext cx="45720" cy="3800000"/>
-          </a:xfrm>
-          <a:prstGeom prst="rect">
-            <a:avLst/>
-          </a:prstGeom>
-          <a:solidFill>
-            <a:srgbClr val="8B5CF6"/>
-          </a:solidFill>
-          <a:ln>
-            <a:noFill/>
-          </a:ln>
-        </p:spPr>
-      </p:sp>
-      <p:pic>
-        <p:nvPicPr>
-          <p:cNvPr id="6" name="Asset visual-supported-paths" descr="Modern portability does not make supported REST API or legacy plugin routes obsolete. (marp diagram)"/>
-          <p:cNvPicPr>
-            <a:picLocks noChangeAspect="1"/>
-          </p:cNvPicPr>
-          <p:nvPr/>
-        </p:nvPicPr>
-        <p:blipFill>
-          <a:blip r:embed="rIdImage1"/>
-          <a:stretch>
-            <a:fillRect/>
-          </a:stretch>
-        </p:blipFill>
-        <p:spPr>
-          <a:xfrm>
-            <a:off x="5000000" y="2021875"/>
-            <a:ext cx="6500000" cy="3656250"/>
-          </a:xfrm>
-          <a:prstGeom prst="rect">
-            <a:avLst/>
-          </a:prstGeom>
-          <a:ln>
-            <a:solidFill>
-              <a:srgbClr val="D9D9D9"/>
-            </a:solidFill>
-          </a:ln>
-        </p:spPr>
-      </p:pic>
-      <p:sp>
-        <p:nvSpPr>
-          <p:cNvPr id="7" name="Footer"/>
-          <p:cNvSpPr txBox="1"/>
-          <p:nvPr/>
-        </p:nvSpPr>
-        <p:spPr>
-          <a:xfrm>
-            <a:off x="685800" y="6250000"/>
-            <a:ext cx="9400000" cy="420000"/>
+              <a:rPr lang="en-US" sz="2900" b="1">
+                <a:solidFill>
+                  <a:srgbClr val="0B121E"/>
+                </a:solidFill>
+                <a:latin typeface="+mj-lt"/>
+              </a:rPr>
+              <a:t>3.</a:t>
+            </a:r>
+            <a:r>
+              <a:rPr lang="en-US" sz="2900" b="1">
+                <a:solidFill>
+                  <a:srgbClr val="006EC3"/>
+                </a:solidFill>
+                <a:latin typeface="+mj-lt"/>
+              </a:rPr>
+              <a:t> Preserve supported paths</a:t>
+            </a:r>
+          </a:p>
+        </p:txBody>
+      </p:sp>
+      <p:sp>
+        <p:nvSpPr>
+          <p:cNvPr id="7" name="Body"/>
+          <p:cNvSpPr txBox="1"/>
+          <p:nvPr/>
+        </p:nvSpPr>
+        <p:spPr>
+          <a:xfrm>
+            <a:off x="685800" y="1950000"/>
+            <a:ext cx="3900000" cy="3900000"/>
           </a:xfrm>
           <a:prstGeom prst="rect">
             <a:avLst/>
@@ -2117,26 +2341,77 @@
               </a:spcAft>
             </a:pPr>
             <a:r>
-              <a:rPr lang="en-US" sz="1000">
-                <a:solidFill>
-                  <a:srgbClr val="B4B5C4"/>
-                </a:solidFill>
-              </a:rPr>
-              <a:t>Sources: MCP and API plugins for declarative agents  ·  About GitHub Copilot plugins</a:t>
-            </a:r>
-          </a:p>
-        </p:txBody>
-      </p:sp>
-      <p:sp>
-        <p:nvSpPr>
-          <p:cNvPr id="8" name="Slide number"/>
-          <p:cNvSpPr txBox="1"/>
-          <p:nvPr/>
-        </p:nvSpPr>
-        <p:spPr>
-          <a:xfrm>
-            <a:off x="10100000" y="6250000"/>
-            <a:ext cx="1400000" cy="420000"/>
+              <a:rPr lang="en-US" sz="2500">
+                <a:solidFill>
+                  <a:srgbClr val="0B121E"/>
+                </a:solidFill>
+              </a:rPr>
+              <a:t>REST API actions remain supported in declarative agents. Agent Plugins 1.0 adds portability, while legacy GitHub Copilot plugins continue to load.</a:t>
+            </a:r>
+          </a:p>
+        </p:txBody>
+      </p:sp>
+      <p:sp>
+        <p:nvSpPr>
+          <p:cNvPr id="8" name="Accent rule"/>
+          <p:cNvSpPr/>
+          <p:nvPr/>
+        </p:nvSpPr>
+        <p:spPr>
+          <a:xfrm>
+            <a:off x="548640" y="2000000"/>
+            <a:ext cx="45720" cy="3800000"/>
+          </a:xfrm>
+          <a:prstGeom prst="rect">
+            <a:avLst/>
+          </a:prstGeom>
+          <a:solidFill>
+            <a:srgbClr val="006EC3"/>
+          </a:solidFill>
+          <a:ln>
+            <a:noFill/>
+          </a:ln>
+        </p:spPr>
+      </p:sp>
+      <p:pic>
+        <p:nvPicPr>
+          <p:cNvPr id="9" name="Asset visual-supported-paths" descr="Modern portability does not make supported REST API or legacy plugin routes obsolete. (marp diagram)"/>
+          <p:cNvPicPr>
+            <a:picLocks noChangeAspect="1"/>
+          </p:cNvPicPr>
+          <p:nvPr/>
+        </p:nvPicPr>
+        <p:blipFill>
+          <a:blip r:embed="rIdImage1"/>
+          <a:stretch>
+            <a:fillRect/>
+          </a:stretch>
+        </p:blipFill>
+        <p:spPr>
+          <a:xfrm>
+            <a:off x="5000000" y="2221875"/>
+            <a:ext cx="6500000" cy="3656250"/>
+          </a:xfrm>
+          <a:prstGeom prst="rect">
+            <a:avLst/>
+          </a:prstGeom>
+          <a:ln>
+            <a:solidFill>
+              <a:srgbClr val="D9D9D9"/>
+            </a:solidFill>
+          </a:ln>
+        </p:spPr>
+      </p:pic>
+      <p:sp>
+        <p:nvSpPr>
+          <p:cNvPr id="10" name="Footer"/>
+          <p:cNvSpPr txBox="1"/>
+          <p:nvPr/>
+        </p:nvSpPr>
+        <p:spPr>
+          <a:xfrm>
+            <a:off x="685800" y="6250000"/>
+            <a:ext cx="10820400" cy="420000"/>
           </a:xfrm>
           <a:prstGeom prst="rect">
             <a:avLst/>
@@ -2152,14 +2427,21 @@
           </a:bodyPr>
           <a:lstStyle/>
           <a:p>
-            <a:pPr algn="r"/>
+            <a:pPr algn="l">
+              <a:lnSpc>
+                <a:spcPct val="105000"/>
+              </a:lnSpc>
+              <a:spcAft>
+                <a:spcPts val="0"/>
+              </a:spcAft>
+            </a:pPr>
             <a:r>
               <a:rPr lang="en-US" sz="1000">
                 <a:solidFill>
-                  <a:srgbClr val="B4B5C4"/>
-                </a:solidFill>
-              </a:rPr>
-              <a:t>4 / 6</a:t>
+                  <a:srgbClr val="64686E"/>
+                </a:solidFill>
+              </a:rPr>
+              <a:t>Sources: MCP and API plugins for declarative agents  ·  About GitHub Copilot plugins</a:t>
             </a:r>
           </a:p>
         </p:txBody>
@@ -2178,7 +2460,7 @@
     <p:bg>
       <p:bgPr>
         <a:solidFill>
-          <a:srgbClr val="08142D"/>
+          <a:srgbClr val="F4F8FC"/>
         </a:solidFill>
         <a:effectLst/>
       </p:bgPr>
@@ -2192,20 +2474,20 @@
       <p:grpSpPr/>
       <p:sp>
         <p:nvSpPr>
-          <p:cNvPr id="2" name="Accent band"/>
+          <p:cNvPr id="2" name="Brand band"/>
           <p:cNvSpPr/>
           <p:nvPr/>
         </p:nvSpPr>
         <p:spPr>
           <a:xfrm>
             <a:off x="0" y="0"/>
-            <a:ext cx="12192000" cy="91440"/>
+            <a:ext cx="12192000" cy="502920"/>
           </a:xfrm>
           <a:prstGeom prst="rect">
             <a:avLst/>
           </a:prstGeom>
           <a:solidFill>
-            <a:srgbClr val="8B5CF6"/>
+            <a:srgbClr val="0E1726"/>
           </a:solidFill>
           <a:ln>
             <a:noFill/>
@@ -2214,14 +2496,36 @@
       </p:sp>
       <p:sp>
         <p:nvSpPr>
-          <p:cNvPr id="3" name="Title"/>
-          <p:cNvSpPr txBox="1"/>
-          <p:nvPr/>
-        </p:nvSpPr>
-        <p:spPr>
-          <a:xfrm>
-            <a:off x="685800" y="420000"/>
-            <a:ext cx="10820400" cy="1150000"/>
+          <p:cNvPr id="3" name="Highlight rule"/>
+          <p:cNvSpPr/>
+          <p:nvPr/>
+        </p:nvSpPr>
+        <p:spPr>
+          <a:xfrm>
+            <a:off x="0" y="502920"/>
+            <a:ext cx="12192000" cy="45720"/>
+          </a:xfrm>
+          <a:prstGeom prst="rect">
+            <a:avLst/>
+          </a:prstGeom>
+          <a:solidFill>
+            <a:srgbClr val="8AC1EB"/>
+          </a:solidFill>
+          <a:ln>
+            <a:noFill/>
+          </a:ln>
+        </p:spPr>
+      </p:sp>
+      <p:sp>
+        <p:nvSpPr>
+          <p:cNvPr id="4" name="Deck kicker"/>
+          <p:cNvSpPr txBox="1"/>
+          <p:nvPr/>
+        </p:nvSpPr>
+        <p:spPr>
+          <a:xfrm>
+            <a:off x="685800" y="0"/>
+            <a:ext cx="8400000" cy="502920"/>
           </a:xfrm>
           <a:prstGeom prst="rect">
             <a:avLst/>
@@ -2246,45 +2550,74 @@
               </a:spcAft>
             </a:pPr>
             <a:r>
-              <a:rPr lang="en-US" sz="2900" b="1">
-                <a:solidFill>
-                  <a:srgbClr val="F7F4FF"/>
-                </a:solidFill>
-              </a:rPr>
-              <a:t>4.</a:t>
-            </a:r>
-            <a:r>
-              <a:rPr lang="en-US" sz="2900" b="1">
-                <a:solidFill>
-                  <a:srgbClr val="8B5CF6"/>
-                </a:solidFill>
-              </a:rPr>
-              <a:t> Govern a small portfolio</a:t>
-            </a:r>
-          </a:p>
-        </p:txBody>
-      </p:sp>
-      <p:sp>
-        <p:nvSpPr>
-          <p:cNvPr id="4" name="Body"/>
-          <p:cNvSpPr txBox="1"/>
-          <p:nvPr/>
-        </p:nvSpPr>
-        <p:spPr>
-          <a:xfrm>
-            <a:off x="685800" y="1750000"/>
-            <a:ext cx="3900000" cy="3900000"/>
-          </a:xfrm>
-          <a:prstGeom prst="rect">
-            <a:avLst/>
-          </a:prstGeom>
-          <a:noFill/>
-          <a:ln>
-            <a:noFill/>
-          </a:ln>
-        </p:spPr>
-        <p:txBody>
-          <a:bodyPr wrap="square" lIns="182880" tIns="91440" rIns="182880" bIns="91440" anchor="t">
+              <a:rPr lang="en-US" sz="1100" b="1" cap="all" spc="120">
+                <a:solidFill>
+                  <a:srgbClr val="FFFFFF"/>
+                </a:solidFill>
+              </a:rPr>
+              <a:t>Microsoft Plugin Architecture</a:t>
+            </a:r>
+          </a:p>
+        </p:txBody>
+      </p:sp>
+      <p:sp>
+        <p:nvSpPr>
+          <p:cNvPr id="5" name="Slide number"/>
+          <p:cNvSpPr txBox="1"/>
+          <p:nvPr/>
+        </p:nvSpPr>
+        <p:spPr>
+          <a:xfrm>
+            <a:off x="9100000" y="0"/>
+            <a:ext cx="2406400" cy="502920"/>
+          </a:xfrm>
+          <a:prstGeom prst="rect">
+            <a:avLst/>
+          </a:prstGeom>
+          <a:noFill/>
+          <a:ln>
+            <a:noFill/>
+          </a:ln>
+        </p:spPr>
+        <p:txBody>
+          <a:bodyPr wrap="square" lIns="182880" tIns="91440" rIns="182880" bIns="91440" anchor="ctr">
+            <a:normAutofit/>
+          </a:bodyPr>
+          <a:lstStyle/>
+          <a:p>
+            <a:pPr algn="r"/>
+            <a:r>
+              <a:rPr lang="en-US" sz="1100" b="1" cap="all" spc="120">
+                <a:solidFill>
+                  <a:srgbClr val="BCBEC2"/>
+                </a:solidFill>
+              </a:rPr>
+              <a:t>5 / 6</a:t>
+            </a:r>
+          </a:p>
+        </p:txBody>
+      </p:sp>
+      <p:sp>
+        <p:nvSpPr>
+          <p:cNvPr id="6" name="Title"/>
+          <p:cNvSpPr txBox="1"/>
+          <p:nvPr/>
+        </p:nvSpPr>
+        <p:spPr>
+          <a:xfrm>
+            <a:off x="685800" y="700000"/>
+            <a:ext cx="10820400" cy="1150000"/>
+          </a:xfrm>
+          <a:prstGeom prst="rect">
+            <a:avLst/>
+          </a:prstGeom>
+          <a:noFill/>
+          <a:ln>
+            <a:noFill/>
+          </a:ln>
+        </p:spPr>
+        <p:txBody>
+          <a:bodyPr wrap="square" lIns="182880" tIns="91440" rIns="182880" bIns="91440" anchor="ctr">
             <a:normAutofit/>
           </a:bodyPr>
           <a:lstStyle/>
@@ -2298,77 +2631,36 @@
               </a:spcAft>
             </a:pPr>
             <a:r>
-              <a:rPr lang="en-US" sz="2400">
-                <a:solidFill>
-                  <a:srgbClr val="F7F4FF"/>
-                </a:solidFill>
-              </a:rPr>
-              <a:t>Assign one owner per capability and service. Publish a host compatibility matrix, version each package, and add routes only when demand justifies lifecycle cost.</a:t>
-            </a:r>
-          </a:p>
-        </p:txBody>
-      </p:sp>
-      <p:sp>
-        <p:nvSpPr>
-          <p:cNvPr id="5" name="Accent rule"/>
-          <p:cNvSpPr/>
-          <p:nvPr/>
-        </p:nvSpPr>
-        <p:spPr>
-          <a:xfrm>
-            <a:off x="548640" y="1800000"/>
-            <a:ext cx="45720" cy="3800000"/>
-          </a:xfrm>
-          <a:prstGeom prst="rect">
-            <a:avLst/>
-          </a:prstGeom>
-          <a:solidFill>
-            <a:srgbClr val="8B5CF6"/>
-          </a:solidFill>
-          <a:ln>
-            <a:noFill/>
-          </a:ln>
-        </p:spPr>
-      </p:sp>
-      <p:pic>
-        <p:nvPicPr>
-          <p:cNvPr id="6" name="Asset visual-portfolio" descr="A small governed portfolio makes compatibility and operational ownership explicit. (marp diagram)"/>
-          <p:cNvPicPr>
-            <a:picLocks noChangeAspect="1"/>
-          </p:cNvPicPr>
-          <p:nvPr/>
-        </p:nvPicPr>
-        <p:blipFill>
-          <a:blip r:embed="rIdImage1"/>
-          <a:stretch>
-            <a:fillRect/>
-          </a:stretch>
-        </p:blipFill>
-        <p:spPr>
-          <a:xfrm>
-            <a:off x="5000000" y="2021875"/>
-            <a:ext cx="6500000" cy="3656250"/>
-          </a:xfrm>
-          <a:prstGeom prst="rect">
-            <a:avLst/>
-          </a:prstGeom>
-          <a:ln>
-            <a:solidFill>
-              <a:srgbClr val="D9D9D9"/>
-            </a:solidFill>
-          </a:ln>
-        </p:spPr>
-      </p:pic>
-      <p:sp>
-        <p:nvSpPr>
-          <p:cNvPr id="7" name="Footer"/>
-          <p:cNvSpPr txBox="1"/>
-          <p:nvPr/>
-        </p:nvSpPr>
-        <p:spPr>
-          <a:xfrm>
-            <a:off x="685800" y="6250000"/>
-            <a:ext cx="9400000" cy="420000"/>
+              <a:rPr lang="en-US" sz="2900" b="1">
+                <a:solidFill>
+                  <a:srgbClr val="0B121E"/>
+                </a:solidFill>
+                <a:latin typeface="+mj-lt"/>
+              </a:rPr>
+              <a:t>4.</a:t>
+            </a:r>
+            <a:r>
+              <a:rPr lang="en-US" sz="2900" b="1">
+                <a:solidFill>
+                  <a:srgbClr val="006EC3"/>
+                </a:solidFill>
+                <a:latin typeface="+mj-lt"/>
+              </a:rPr>
+              <a:t> Govern a small portfolio</a:t>
+            </a:r>
+          </a:p>
+        </p:txBody>
+      </p:sp>
+      <p:sp>
+        <p:nvSpPr>
+          <p:cNvPr id="7" name="Body"/>
+          <p:cNvSpPr txBox="1"/>
+          <p:nvPr/>
+        </p:nvSpPr>
+        <p:spPr>
+          <a:xfrm>
+            <a:off x="685800" y="1950000"/>
+            <a:ext cx="3900000" cy="3900000"/>
           </a:xfrm>
           <a:prstGeom prst="rect">
             <a:avLst/>
@@ -2393,26 +2685,77 @@
               </a:spcAft>
             </a:pPr>
             <a:r>
-              <a:rPr lang="en-US" sz="1000">
-                <a:solidFill>
-                  <a:srgbClr val="B4B5C4"/>
-                </a:solidFill>
-              </a:rPr>
-              <a:t>Sources: Build plugins for Copilot Cowork  ·  MCP and API plugins for declarative agents  ·  About GitHub Copilot plugins</a:t>
-            </a:r>
-          </a:p>
-        </p:txBody>
-      </p:sp>
-      <p:sp>
-        <p:nvSpPr>
-          <p:cNvPr id="8" name="Slide number"/>
-          <p:cNvSpPr txBox="1"/>
-          <p:nvPr/>
-        </p:nvSpPr>
-        <p:spPr>
-          <a:xfrm>
-            <a:off x="10100000" y="6250000"/>
-            <a:ext cx="1400000" cy="420000"/>
+              <a:rPr lang="en-US" sz="2400">
+                <a:solidFill>
+                  <a:srgbClr val="0B121E"/>
+                </a:solidFill>
+              </a:rPr>
+              <a:t>Assign one owner per capability and service. Publish a host compatibility matrix, version each package, and add routes only when demand justifies lifecycle cost.</a:t>
+            </a:r>
+          </a:p>
+        </p:txBody>
+      </p:sp>
+      <p:sp>
+        <p:nvSpPr>
+          <p:cNvPr id="8" name="Accent rule"/>
+          <p:cNvSpPr/>
+          <p:nvPr/>
+        </p:nvSpPr>
+        <p:spPr>
+          <a:xfrm>
+            <a:off x="548640" y="2000000"/>
+            <a:ext cx="45720" cy="3800000"/>
+          </a:xfrm>
+          <a:prstGeom prst="rect">
+            <a:avLst/>
+          </a:prstGeom>
+          <a:solidFill>
+            <a:srgbClr val="006EC3"/>
+          </a:solidFill>
+          <a:ln>
+            <a:noFill/>
+          </a:ln>
+        </p:spPr>
+      </p:sp>
+      <p:pic>
+        <p:nvPicPr>
+          <p:cNvPr id="9" name="Asset visual-portfolio" descr="A small governed portfolio makes compatibility and operational ownership explicit. (marp diagram)"/>
+          <p:cNvPicPr>
+            <a:picLocks noChangeAspect="1"/>
+          </p:cNvPicPr>
+          <p:nvPr/>
+        </p:nvPicPr>
+        <p:blipFill>
+          <a:blip r:embed="rIdImage1"/>
+          <a:stretch>
+            <a:fillRect/>
+          </a:stretch>
+        </p:blipFill>
+        <p:spPr>
+          <a:xfrm>
+            <a:off x="5000000" y="2221875"/>
+            <a:ext cx="6500000" cy="3656250"/>
+          </a:xfrm>
+          <a:prstGeom prst="rect">
+            <a:avLst/>
+          </a:prstGeom>
+          <a:ln>
+            <a:solidFill>
+              <a:srgbClr val="D9D9D9"/>
+            </a:solidFill>
+          </a:ln>
+        </p:spPr>
+      </p:pic>
+      <p:sp>
+        <p:nvSpPr>
+          <p:cNvPr id="10" name="Footer"/>
+          <p:cNvSpPr txBox="1"/>
+          <p:nvPr/>
+        </p:nvSpPr>
+        <p:spPr>
+          <a:xfrm>
+            <a:off x="685800" y="6250000"/>
+            <a:ext cx="10820400" cy="420000"/>
           </a:xfrm>
           <a:prstGeom prst="rect">
             <a:avLst/>
@@ -2428,14 +2771,21 @@
           </a:bodyPr>
           <a:lstStyle/>
           <a:p>
-            <a:pPr algn="r"/>
+            <a:pPr algn="l">
+              <a:lnSpc>
+                <a:spcPct val="105000"/>
+              </a:lnSpc>
+              <a:spcAft>
+                <a:spcPts val="0"/>
+              </a:spcAft>
+            </a:pPr>
             <a:r>
               <a:rPr lang="en-US" sz="1000">
                 <a:solidFill>
-                  <a:srgbClr val="B4B5C4"/>
-                </a:solidFill>
-              </a:rPr>
-              <a:t>5 / 6</a:t>
+                  <a:srgbClr val="64686E"/>
+                </a:solidFill>
+              </a:rPr>
+              <a:t>Sources: Build plugins for Copilot Cowork  ·  MCP and API plugins for declarative agents  ·  About GitHub Copilot plugins</a:t>
             </a:r>
           </a:p>
         </p:txBody>
@@ -2454,7 +2804,7 @@
     <p:bg>
       <p:bgPr>
         <a:solidFill>
-          <a:srgbClr val="08142D"/>
+          <a:srgbClr val="F4F8FC"/>
         </a:solidFill>
         <a:effectLst/>
       </p:bgPr>
@@ -2468,20 +2818,20 @@
       <p:grpSpPr/>
       <p:sp>
         <p:nvSpPr>
-          <p:cNvPr id="2" name="Accent band"/>
+          <p:cNvPr id="2" name="Brand band"/>
           <p:cNvSpPr/>
           <p:nvPr/>
         </p:nvSpPr>
         <p:spPr>
           <a:xfrm>
             <a:off x="0" y="0"/>
-            <a:ext cx="12192000" cy="91440"/>
+            <a:ext cx="12192000" cy="502920"/>
           </a:xfrm>
           <a:prstGeom prst="rect">
             <a:avLst/>
           </a:prstGeom>
           <a:solidFill>
-            <a:srgbClr val="8B5CF6"/>
+            <a:srgbClr val="0E1726"/>
           </a:solidFill>
           <a:ln>
             <a:noFill/>
@@ -2490,14 +2840,36 @@
       </p:sp>
       <p:sp>
         <p:nvSpPr>
-          <p:cNvPr id="3" name="Title"/>
-          <p:cNvSpPr txBox="1"/>
-          <p:nvPr/>
-        </p:nvSpPr>
-        <p:spPr>
-          <a:xfrm>
-            <a:off x="685800" y="420000"/>
-            <a:ext cx="10820400" cy="1000000"/>
+          <p:cNvPr id="3" name="Highlight rule"/>
+          <p:cNvSpPr/>
+          <p:nvPr/>
+        </p:nvSpPr>
+        <p:spPr>
+          <a:xfrm>
+            <a:off x="0" y="502920"/>
+            <a:ext cx="12192000" cy="45720"/>
+          </a:xfrm>
+          <a:prstGeom prst="rect">
+            <a:avLst/>
+          </a:prstGeom>
+          <a:solidFill>
+            <a:srgbClr val="8AC1EB"/>
+          </a:solidFill>
+          <a:ln>
+            <a:noFill/>
+          </a:ln>
+        </p:spPr>
+      </p:sp>
+      <p:sp>
+        <p:nvSpPr>
+          <p:cNvPr id="4" name="Deck kicker"/>
+          <p:cNvSpPr txBox="1"/>
+          <p:nvPr/>
+        </p:nvSpPr>
+        <p:spPr>
+          <a:xfrm>
+            <a:off x="685800" y="0"/>
+            <a:ext cx="8400000" cy="502920"/>
           </a:xfrm>
           <a:prstGeom prst="rect">
             <a:avLst/>
@@ -2522,45 +2894,74 @@
               </a:spcAft>
             </a:pPr>
             <a:r>
-              <a:rPr lang="en-US" sz="2400" b="1">
-                <a:solidFill>
-                  <a:srgbClr val="F7F4FF"/>
-                </a:solidFill>
-              </a:rPr>
-              <a:t>Sources.</a:t>
-            </a:r>
-            <a:r>
-              <a:rPr lang="en-US" sz="2400" b="1">
-                <a:solidFill>
-                  <a:srgbClr val="8B5CF6"/>
-                </a:solidFill>
-              </a:rPr>
-              <a:t> Every claim traces to one.</a:t>
-            </a:r>
-          </a:p>
-        </p:txBody>
-      </p:sp>
-      <p:sp>
-        <p:nvSpPr>
-          <p:cNvPr id="4" name="Sources"/>
-          <p:cNvSpPr txBox="1"/>
-          <p:nvPr/>
-        </p:nvSpPr>
-        <p:spPr>
-          <a:xfrm>
-            <a:off x="685800" y="1700000"/>
-            <a:ext cx="10820400" cy="4300000"/>
-          </a:xfrm>
-          <a:prstGeom prst="rect">
-            <a:avLst/>
-          </a:prstGeom>
-          <a:noFill/>
-          <a:ln>
-            <a:noFill/>
-          </a:ln>
-        </p:spPr>
-        <p:txBody>
-          <a:bodyPr wrap="square" lIns="182880" tIns="91440" rIns="182880" bIns="91440" anchor="t">
+              <a:rPr lang="en-US" sz="1100" b="1" cap="all" spc="120">
+                <a:solidFill>
+                  <a:srgbClr val="FFFFFF"/>
+                </a:solidFill>
+              </a:rPr>
+              <a:t>Microsoft Plugin Architecture</a:t>
+            </a:r>
+          </a:p>
+        </p:txBody>
+      </p:sp>
+      <p:sp>
+        <p:nvSpPr>
+          <p:cNvPr id="5" name="Slide number"/>
+          <p:cNvSpPr txBox="1"/>
+          <p:nvPr/>
+        </p:nvSpPr>
+        <p:spPr>
+          <a:xfrm>
+            <a:off x="9100000" y="0"/>
+            <a:ext cx="2406400" cy="502920"/>
+          </a:xfrm>
+          <a:prstGeom prst="rect">
+            <a:avLst/>
+          </a:prstGeom>
+          <a:noFill/>
+          <a:ln>
+            <a:noFill/>
+          </a:ln>
+        </p:spPr>
+        <p:txBody>
+          <a:bodyPr wrap="square" lIns="182880" tIns="91440" rIns="182880" bIns="91440" anchor="ctr">
+            <a:normAutofit/>
+          </a:bodyPr>
+          <a:lstStyle/>
+          <a:p>
+            <a:pPr algn="r"/>
+            <a:r>
+              <a:rPr lang="en-US" sz="1100" b="1" cap="all" spc="120">
+                <a:solidFill>
+                  <a:srgbClr val="BCBEC2"/>
+                </a:solidFill>
+              </a:rPr>
+              <a:t>6 / 6</a:t>
+            </a:r>
+          </a:p>
+        </p:txBody>
+      </p:sp>
+      <p:sp>
+        <p:nvSpPr>
+          <p:cNvPr id="6" name="Title"/>
+          <p:cNvSpPr txBox="1"/>
+          <p:nvPr/>
+        </p:nvSpPr>
+        <p:spPr>
+          <a:xfrm>
+            <a:off x="685800" y="760000"/>
+            <a:ext cx="10820400" cy="1000000"/>
+          </a:xfrm>
+          <a:prstGeom prst="rect">
+            <a:avLst/>
+          </a:prstGeom>
+          <a:noFill/>
+          <a:ln>
+            <a:noFill/>
+          </a:ln>
+        </p:spPr>
+        <p:txBody>
+          <a:bodyPr wrap="square" lIns="182880" tIns="91440" rIns="182880" bIns="91440" anchor="ctr">
             <a:normAutofit/>
           </a:bodyPr>
           <a:lstStyle/>
@@ -2574,9 +2975,63 @@
               </a:spcAft>
             </a:pPr>
             <a:r>
+              <a:rPr lang="en-US" sz="2400" b="1">
+                <a:solidFill>
+                  <a:srgbClr val="0B121E"/>
+                </a:solidFill>
+                <a:latin typeface="+mj-lt"/>
+              </a:rPr>
+              <a:t>Sources.</a:t>
+            </a:r>
+            <a:r>
+              <a:rPr lang="en-US" sz="2400" b="1">
+                <a:solidFill>
+                  <a:srgbClr val="006EC3"/>
+                </a:solidFill>
+                <a:latin typeface="+mj-lt"/>
+              </a:rPr>
+              <a:t> Every claim traces to one.</a:t>
+            </a:r>
+          </a:p>
+        </p:txBody>
+      </p:sp>
+      <p:sp>
+        <p:nvSpPr>
+          <p:cNvPr id="7" name="Sources"/>
+          <p:cNvSpPr txBox="1"/>
+          <p:nvPr/>
+        </p:nvSpPr>
+        <p:spPr>
+          <a:xfrm>
+            <a:off x="685800" y="1900000"/>
+            <a:ext cx="10820400" cy="4300000"/>
+          </a:xfrm>
+          <a:prstGeom prst="rect">
+            <a:avLst/>
+          </a:prstGeom>
+          <a:noFill/>
+          <a:ln>
+            <a:noFill/>
+          </a:ln>
+        </p:spPr>
+        <p:txBody>
+          <a:bodyPr wrap="square" lIns="182880" tIns="91440" rIns="182880" bIns="91440" anchor="t">
+            <a:normAutofit/>
+          </a:bodyPr>
+          <a:lstStyle/>
+          <a:p>
+            <a:pPr algn="l">
+              <a:lnSpc>
+                <a:spcPct val="105000"/>
+              </a:lnSpc>
+              <a:spcAft>
+                <a:spcPts val="0"/>
+              </a:spcAft>
+            </a:pPr>
+            <a:r>
               <a:rPr lang="en-US" sz="1400" b="1">
                 <a:solidFill>
-                  <a:srgbClr val="F7F4FF"/>
+                  <a:srgbClr val="0B121E"/>
                 </a:solidFill>
               </a:rPr>
               <a:t>Build plugins for Copilot Cowork</a:t>
@@ -2584,7 +3039,7 @@
             <a:r>
               <a:rPr lang="en-US" sz="1100">
                 <a:solidFill>
-                  <a:srgbClr val="B4B5C4"/>
+                  <a:srgbClr val="64686E"/>
                 </a:solidFill>
               </a:rPr>
               <a:t>  retrieved 2026-10-06</a:t>
@@ -2602,7 +3057,7 @@
             <a:r>
               <a:rPr lang="en-US" sz="1100">
                 <a:solidFill>
-                  <a:srgbClr val="8B5CF6"/>
+                  <a:srgbClr val="006EC3"/>
                 </a:solidFill>
               </a:rPr>
               <a:t>https://learn.microsoft.com/en-us/microsoft-365/copilot/cowork/cowork-plugin-development</a:t>
@@ -2620,7 +3075,7 @@
             <a:r>
               <a:rPr lang="en-US" sz="1400" b="1">
                 <a:solidFill>
-                  <a:srgbClr val="F7F4FF"/>
+                  <a:srgbClr val="0B121E"/>
                 </a:solidFill>
               </a:rPr>
               <a:t>MCP and API plugins for declarative agents</a:t>
@@ -2628,7 +3083,7 @@
             <a:r>
               <a:rPr lang="en-US" sz="1100">
                 <a:solidFill>
-                  <a:srgbClr val="B4B5C4"/>
+                  <a:srgbClr val="64686E"/>
                 </a:solidFill>
               </a:rPr>
               <a:t>  retrieved 2026-10-06</a:t>
@@ -2646,7 +3101,7 @@
             <a:r>
               <a:rPr lang="en-US" sz="1100">
                 <a:solidFill>
-                  <a:srgbClr val="8B5CF6"/>
+                  <a:srgbClr val="006EC3"/>
                 </a:solidFill>
               </a:rPr>
               <a:t>https://learn.microsoft.com/en-us/microsoft-365/copilot/extensibility/overview-plugins</a:t>
@@ -2664,7 +3119,7 @@
             <a:r>
               <a:rPr lang="en-US" sz="1400" b="1">
                 <a:solidFill>
-                  <a:srgbClr val="F7F4FF"/>
+                  <a:srgbClr val="0B121E"/>
                 </a:solidFill>
               </a:rPr>
               <a:t>About GitHub Copilot plugins</a:t>
@@ -2672,7 +3127,7 @@
             <a:r>
               <a:rPr lang="en-US" sz="1100">
                 <a:solidFill>
-                  <a:srgbClr val="B4B5C4"/>
+                  <a:srgbClr val="64686E"/>
                 </a:solidFill>
               </a:rPr>
               <a:t>  retrieved 2026-10-06</a:t>
@@ -2690,7 +3145,7 @@
             <a:r>
               <a:rPr lang="en-US" sz="1100">
                 <a:solidFill>
-                  <a:srgbClr val="8B5CF6"/>
+                  <a:srgbClr val="006EC3"/>
                 </a:solidFill>
               </a:rPr>
               <a:t>https://docs.github.com/en/copilot/concepts/agents/about-plugins</a:t>
@@ -2700,14 +3155,14 @@
       </p:sp>
       <p:sp>
         <p:nvSpPr>
-          <p:cNvPr id="5" name="Footer"/>
+          <p:cNvPr id="8" name="Footer"/>
           <p:cNvSpPr txBox="1"/>
           <p:nvPr/>
         </p:nvSpPr>
         <p:spPr>
           <a:xfrm>
             <a:off x="685800" y="6250000"/>
-            <a:ext cx="9400000" cy="420000"/>
+            <a:ext cx="10820400" cy="420000"/>
           </a:xfrm>
           <a:prstGeom prst="rect">
             <a:avLst/>
@@ -2734,47 +3189,10 @@
             <a:r>
               <a:rPr lang="en-US" sz="1000">
                 <a:solidFill>
-                  <a:srgbClr val="B4B5C4"/>
-                </a:solidFill>
-              </a:rPr>
-              <a:t>microsoft-plugin-architecture-2026-05-am-michael-kokoro-onnx</a:t>
-            </a:r>
-          </a:p>
-        </p:txBody>
-      </p:sp>
-      <p:sp>
-        <p:nvSpPr>
-          <p:cNvPr id="6" name="Slide number"/>
-          <p:cNvSpPr txBox="1"/>
-          <p:nvPr/>
-        </p:nvSpPr>
-        <p:spPr>
-          <a:xfrm>
-            <a:off x="10100000" y="6250000"/>
-            <a:ext cx="1400000" cy="420000"/>
-          </a:xfrm>
-          <a:prstGeom prst="rect">
-            <a:avLst/>
-          </a:prstGeom>
-          <a:noFill/>
-          <a:ln>
-            <a:noFill/>
-          </a:ln>
-        </p:spPr>
-        <p:txBody>
-          <a:bodyPr wrap="square" lIns="182880" tIns="91440" rIns="182880" bIns="91440" anchor="t">
-            <a:normAutofit/>
-          </a:bodyPr>
-          <a:lstStyle/>
-          <a:p>
-            <a:pPr algn="r"/>
-            <a:r>
-              <a:rPr lang="en-US" sz="1000">
-                <a:solidFill>
-                  <a:srgbClr val="B4B5C4"/>
-                </a:solidFill>
-              </a:rPr>
-              <a:t>6 / 6</a:t>
+                  <a:srgbClr val="64686E"/>
+                </a:solidFill>
+              </a:rPr>
+              <a:t>microsoft-plugin-architecture-2026-06-am-michael-kokoro-onnx</a:t>
             </a:r>
           </a:p>
         </p:txBody>
@@ -2788,59 +3206,59 @@
 </file>
 
 <file path=ppt/theme/theme1.xml><?xml version="1.0" encoding="utf-8"?>
-<a:theme xmlns:a="http://schemas.openxmlformats.org/drawingml/2006/main" name="executive-blue-violet">
+<a:theme xmlns:a="http://schemas.openxmlformats.org/drawingml/2006/main" name="microsoft-plugin-architecture-brand">
   <a:themeElements>
-    <a:clrScheme name="executive-blue-violet">
+    <a:clrScheme name="microsoft-plugin-architecture-brand">
       <a:dk1>
-        <a:srgbClr val="F7F4FF"/>
+        <a:srgbClr val="0B121E"/>
       </a:dk1>
       <a:lt1>
-        <a:srgbClr val="08142D"/>
+        <a:srgbClr val="F4F8FC"/>
       </a:lt1>
       <a:dk2>
-        <a:srgbClr val="1F1F1F"/>
+        <a:srgbClr val="0E1726"/>
       </a:dk2>
       <a:lt2>
-        <a:srgbClr val="F8F8F8"/>
+        <a:srgbClr val="E6F1F9"/>
       </a:lt2>
       <a:accent1>
-        <a:srgbClr val="8B5CF6"/>
+        <a:srgbClr val="006EC3"/>
       </a:accent1>
       <a:accent2>
-        <a:srgbClr val="5B9BD5"/>
+        <a:srgbClr val="8AC1EB"/>
       </a:accent2>
       <a:accent3>
-        <a:srgbClr val="70AD47"/>
+        <a:srgbClr val="006EC3"/>
       </a:accent3>
       <a:accent4>
-        <a:srgbClr val="FFC000"/>
+        <a:srgbClr val="090F19"/>
       </a:accent4>
       <a:accent5>
-        <a:srgbClr val="C00000"/>
+        <a:srgbClr val="64686E"/>
       </a:accent5>
       <a:accent6>
-        <a:srgbClr val="7030A0"/>
+        <a:srgbClr val="B42318"/>
       </a:accent6>
       <a:hlink>
-        <a:srgbClr val="8B5CF6"/>
+        <a:srgbClr val="006EC3"/>
       </a:hlink>
       <a:folHlink>
-        <a:srgbClr val="7F7F7F"/>
+        <a:srgbClr val="64686E"/>
       </a:folHlink>
     </a:clrScheme>
-    <a:fontScheme name="executive-blue-violet">
+    <a:fontScheme name="microsoft-plugin-architecture-brand">
       <a:majorFont>
-        <a:latin typeface="Arial"/>
+        <a:latin typeface="Segoe UI Variable Display"/>
         <a:ea typeface=""/>
         <a:cs typeface=""/>
       </a:majorFont>
       <a:minorFont>
-        <a:latin typeface="Arial"/>
+        <a:latin typeface="Segoe UI"/>
         <a:ea typeface=""/>
         <a:cs typeface=""/>
       </a:minorFont>
     </a:fontScheme>
-    <a:fmtScheme name="executive-blue-violet">
+    <a:fmtScheme name="microsoft-plugin-architecture-brand">
       <a:fillStyleLst>
         <a:solidFill>
           <a:schemeClr val="phClr"/>

</xml_diff>

<commit_message>
feat: regenerate microsoft-plugin-architecture on media adapter 13
- render four voices with source-seeded Excalidraw strokes
- add video and spatial spectrograms and internal/external alignment evidence

🎨 - Generated by Copilot

Co-authored-by: Copilot <223556219+Copilot@users.noreply.github.com>
</commit_message>
<xml_diff>
--- a/projects/microsoft-plugin-architecture/release/outputs/deck.pptx
+++ b/projects/microsoft-plugin-architecture/release/outputs/deck.pptx
@@ -1409,7 +1409,7 @@
                   <a:srgbClr val="64686E"/>
                 </a:solidFill>
               </a:rPr>
-              <a:t>microsoft-plugin-architecture-2026-06-am-michael-kokoro-onnx</a:t>
+              <a:t>microsoft-plugin-architecture-2026-07-am-michael-kokoro-onnx</a:t>
             </a:r>
           </a:p>
         </p:txBody>
@@ -3192,7 +3192,7 @@
                   <a:srgbClr val="64686E"/>
                 </a:solidFill>
               </a:rPr>
-              <a:t>microsoft-plugin-architecture-2026-06-am-michael-kokoro-onnx</a:t>
+              <a:t>microsoft-plugin-architecture-2026-07-am-michael-kokoro-onnx</a:t>
             </a:r>
           </a:p>
         </p:txBody>

</xml_diff>